<commit_message>
add system design presentation
</commit_message>
<xml_diff>
--- a/presentation/פרויקט עיצוב התנהגות.pptx - אפיון.pptx
+++ b/presentation/פרויקט עיצוב התנהגות.pptx - אפיון.pptx
@@ -4,10 +4,33 @@
   <p:sldMasterIdLst>
     <p:sldMasterId id="2147483648" r:id="rId1"/>
   </p:sldMasterIdLst>
+  <p:notesMasterIdLst>
+    <p:notesMasterId r:id="rId25"/>
+  </p:notesMasterIdLst>
   <p:sldIdLst>
     <p:sldId id="256" r:id="rId2"/>
-    <p:sldId id="257" r:id="rId3"/>
-    <p:sldId id="258" r:id="rId4"/>
+    <p:sldId id="265" r:id="rId3"/>
+    <p:sldId id="266" r:id="rId4"/>
+    <p:sldId id="267" r:id="rId5"/>
+    <p:sldId id="268" r:id="rId6"/>
+    <p:sldId id="269" r:id="rId7"/>
+    <p:sldId id="270" r:id="rId8"/>
+    <p:sldId id="271" r:id="rId9"/>
+    <p:sldId id="272" r:id="rId10"/>
+    <p:sldId id="273" r:id="rId11"/>
+    <p:sldId id="274" r:id="rId12"/>
+    <p:sldId id="275" r:id="rId13"/>
+    <p:sldId id="276" r:id="rId14"/>
+    <p:sldId id="277" r:id="rId15"/>
+    <p:sldId id="278" r:id="rId16"/>
+    <p:sldId id="279" r:id="rId17"/>
+    <p:sldId id="280" r:id="rId18"/>
+    <p:sldId id="281" r:id="rId19"/>
+    <p:sldId id="282" r:id="rId20"/>
+    <p:sldId id="283" r:id="rId21"/>
+    <p:sldId id="284" r:id="rId22"/>
+    <p:sldId id="285" r:id="rId23"/>
+    <p:sldId id="286" r:id="rId24"/>
   </p:sldIdLst>
   <p:sldSz cx="12192000" cy="6858000"/>
   <p:notesSz cx="6858000" cy="9144000"/>
@@ -114,6 +137,442 @@
 </p:presentation>
 </file>
 
+<file path=ppt/notesMasters/notesMaster1.xml><?xml version="1.0" encoding="utf-8"?>
+<p:notesMaster xmlns:a="http://schemas.openxmlformats.org/drawingml/2006/main" xmlns:r="http://schemas.openxmlformats.org/officeDocument/2006/relationships" xmlns:p="http://schemas.openxmlformats.org/presentationml/2006/main">
+  <p:cSld>
+    <p:bg>
+      <p:bgRef idx="1001">
+        <a:schemeClr val="bg1"/>
+      </p:bgRef>
+    </p:bg>
+    <p:spTree>
+      <p:nvGrpSpPr>
+        <p:cNvPr id="1" name=""/>
+        <p:cNvGrpSpPr/>
+        <p:nvPr/>
+      </p:nvGrpSpPr>
+      <p:grpSpPr>
+        <a:xfrm>
+          <a:off x="0" y="0"/>
+          <a:ext cx="0" cy="0"/>
+          <a:chOff x="0" y="0"/>
+          <a:chExt cx="0" cy="0"/>
+        </a:xfrm>
+      </p:grpSpPr>
+      <p:sp>
+        <p:nvSpPr>
+          <p:cNvPr id="2" name="מציין מיקום של כותרת עליונה 1"/>
+          <p:cNvSpPr>
+            <a:spLocks noGrp="1"/>
+          </p:cNvSpPr>
+          <p:nvPr>
+            <p:ph type="hdr" sz="quarter"/>
+          </p:nvPr>
+        </p:nvSpPr>
+        <p:spPr>
+          <a:xfrm>
+            <a:off x="3886200" y="0"/>
+            <a:ext cx="2971800" cy="458788"/>
+          </a:xfrm>
+          <a:prstGeom prst="rect">
+            <a:avLst/>
+          </a:prstGeom>
+        </p:spPr>
+        <p:txBody>
+          <a:bodyPr vert="horz" lIns="91440" tIns="45720" rIns="91440" bIns="45720" rtlCol="1"/>
+          <a:lstStyle>
+            <a:lvl1pPr algn="r">
+              <a:defRPr sz="1200"/>
+            </a:lvl1pPr>
+          </a:lstStyle>
+          <a:p>
+            <a:endParaRPr lang="he-IL"/>
+          </a:p>
+        </p:txBody>
+      </p:sp>
+      <p:sp>
+        <p:nvSpPr>
+          <p:cNvPr id="3" name="מציין מיקום של תאריך 2"/>
+          <p:cNvSpPr>
+            <a:spLocks noGrp="1"/>
+          </p:cNvSpPr>
+          <p:nvPr>
+            <p:ph type="dt" idx="1"/>
+          </p:nvPr>
+        </p:nvSpPr>
+        <p:spPr>
+          <a:xfrm>
+            <a:off x="1588" y="0"/>
+            <a:ext cx="2971800" cy="458788"/>
+          </a:xfrm>
+          <a:prstGeom prst="rect">
+            <a:avLst/>
+          </a:prstGeom>
+        </p:spPr>
+        <p:txBody>
+          <a:bodyPr vert="horz" lIns="91440" tIns="45720" rIns="91440" bIns="45720" rtlCol="1"/>
+          <a:lstStyle>
+            <a:lvl1pPr algn="l">
+              <a:defRPr sz="1200"/>
+            </a:lvl1pPr>
+          </a:lstStyle>
+          <a:p>
+            <a:fld id="{955A3782-EC98-4CD5-B4ED-BF95D5430A61}" type="datetimeFigureOut">
+              <a:rPr lang="he-IL" smtClean="0"/>
+              <a:t>ט"ז/שבט/תשפ"ו</a:t>
+            </a:fld>
+            <a:endParaRPr lang="he-IL"/>
+          </a:p>
+        </p:txBody>
+      </p:sp>
+      <p:sp>
+        <p:nvSpPr>
+          <p:cNvPr id="4" name="מציין מיקום של תמונת שקופית 3"/>
+          <p:cNvSpPr>
+            <a:spLocks noGrp="1" noRot="1" noChangeAspect="1"/>
+          </p:cNvSpPr>
+          <p:nvPr>
+            <p:ph type="sldImg" idx="2"/>
+          </p:nvPr>
+        </p:nvSpPr>
+        <p:spPr>
+          <a:xfrm>
+            <a:off x="685800" y="1143000"/>
+            <a:ext cx="5486400" cy="3086100"/>
+          </a:xfrm>
+          <a:prstGeom prst="rect">
+            <a:avLst/>
+          </a:prstGeom>
+          <a:noFill/>
+          <a:ln w="12700">
+            <a:solidFill>
+              <a:prstClr val="black"/>
+            </a:solidFill>
+          </a:ln>
+        </p:spPr>
+        <p:txBody>
+          <a:bodyPr vert="horz" lIns="91440" tIns="45720" rIns="91440" bIns="45720" rtlCol="1" anchor="ctr"/>
+          <a:lstStyle/>
+          <a:p>
+            <a:endParaRPr lang="he-IL"/>
+          </a:p>
+        </p:txBody>
+      </p:sp>
+      <p:sp>
+        <p:nvSpPr>
+          <p:cNvPr id="5" name="מציין מיקום של הערות 4"/>
+          <p:cNvSpPr>
+            <a:spLocks noGrp="1"/>
+          </p:cNvSpPr>
+          <p:nvPr>
+            <p:ph type="body" sz="quarter" idx="3"/>
+          </p:nvPr>
+        </p:nvSpPr>
+        <p:spPr>
+          <a:xfrm>
+            <a:off x="685800" y="4400550"/>
+            <a:ext cx="5486400" cy="3600450"/>
+          </a:xfrm>
+          <a:prstGeom prst="rect">
+            <a:avLst/>
+          </a:prstGeom>
+        </p:spPr>
+        <p:txBody>
+          <a:bodyPr vert="horz" lIns="91440" tIns="45720" rIns="91440" bIns="45720" rtlCol="1"/>
+          <a:lstStyle/>
+          <a:p>
+            <a:pPr lvl="0"/>
+            <a:r>
+              <a:rPr lang="he-IL"/>
+              <a:t>לחץ כדי לערוך סגנונות טקסט של תבנית בסיס</a:t>
+            </a:r>
+          </a:p>
+          <a:p>
+            <a:pPr lvl="1"/>
+            <a:r>
+              <a:rPr lang="he-IL"/>
+              <a:t>רמה שנייה</a:t>
+            </a:r>
+          </a:p>
+          <a:p>
+            <a:pPr lvl="2"/>
+            <a:r>
+              <a:rPr lang="he-IL"/>
+              <a:t>רמה שלישית</a:t>
+            </a:r>
+          </a:p>
+          <a:p>
+            <a:pPr lvl="3"/>
+            <a:r>
+              <a:rPr lang="he-IL"/>
+              <a:t>רמה רביעית</a:t>
+            </a:r>
+          </a:p>
+          <a:p>
+            <a:pPr lvl="4"/>
+            <a:r>
+              <a:rPr lang="he-IL"/>
+              <a:t>רמה חמישית</a:t>
+            </a:r>
+          </a:p>
+        </p:txBody>
+      </p:sp>
+      <p:sp>
+        <p:nvSpPr>
+          <p:cNvPr id="6" name="מציין מיקום של כותרת תחתונה 5"/>
+          <p:cNvSpPr>
+            <a:spLocks noGrp="1"/>
+          </p:cNvSpPr>
+          <p:nvPr>
+            <p:ph type="ftr" sz="quarter" idx="4"/>
+          </p:nvPr>
+        </p:nvSpPr>
+        <p:spPr>
+          <a:xfrm>
+            <a:off x="3886200" y="8685213"/>
+            <a:ext cx="2971800" cy="458787"/>
+          </a:xfrm>
+          <a:prstGeom prst="rect">
+            <a:avLst/>
+          </a:prstGeom>
+        </p:spPr>
+        <p:txBody>
+          <a:bodyPr vert="horz" lIns="91440" tIns="45720" rIns="91440" bIns="45720" rtlCol="1" anchor="b"/>
+          <a:lstStyle>
+            <a:lvl1pPr algn="r">
+              <a:defRPr sz="1200"/>
+            </a:lvl1pPr>
+          </a:lstStyle>
+          <a:p>
+            <a:endParaRPr lang="he-IL"/>
+          </a:p>
+        </p:txBody>
+      </p:sp>
+      <p:sp>
+        <p:nvSpPr>
+          <p:cNvPr id="7" name="מציין מיקום של מספר שקופית 6"/>
+          <p:cNvSpPr>
+            <a:spLocks noGrp="1"/>
+          </p:cNvSpPr>
+          <p:nvPr>
+            <p:ph type="sldNum" sz="quarter" idx="5"/>
+          </p:nvPr>
+        </p:nvSpPr>
+        <p:spPr>
+          <a:xfrm>
+            <a:off x="1588" y="8685213"/>
+            <a:ext cx="2971800" cy="458787"/>
+          </a:xfrm>
+          <a:prstGeom prst="rect">
+            <a:avLst/>
+          </a:prstGeom>
+        </p:spPr>
+        <p:txBody>
+          <a:bodyPr vert="horz" lIns="91440" tIns="45720" rIns="91440" bIns="45720" rtlCol="1" anchor="b"/>
+          <a:lstStyle>
+            <a:lvl1pPr algn="l">
+              <a:defRPr sz="1200"/>
+            </a:lvl1pPr>
+          </a:lstStyle>
+          <a:p>
+            <a:fld id="{8060B56F-2397-451C-B624-2F02EEC03C5E}" type="slidenum">
+              <a:rPr lang="he-IL" smtClean="0"/>
+              <a:t>‹#›</a:t>
+            </a:fld>
+            <a:endParaRPr lang="he-IL"/>
+          </a:p>
+        </p:txBody>
+      </p:sp>
+    </p:spTree>
+    <p:extLst>
+      <p:ext uri="{BB962C8B-B14F-4D97-AF65-F5344CB8AC3E}">
+        <p14:creationId xmlns:p14="http://schemas.microsoft.com/office/powerpoint/2010/main" val="29350015"/>
+      </p:ext>
+    </p:extLst>
+  </p:cSld>
+  <p:clrMap bg1="lt1" tx1="dk1" bg2="lt2" tx2="dk2" accent1="accent1" accent2="accent2" accent3="accent3" accent4="accent4" accent5="accent5" accent6="accent6" hlink="hlink" folHlink="folHlink"/>
+  <p:notesStyle>
+    <a:lvl1pPr marL="0" algn="r" defTabSz="914400" rtl="1" eaLnBrk="1" latinLnBrk="0" hangingPunct="1">
+      <a:defRPr sz="1200" kern="1200">
+        <a:solidFill>
+          <a:schemeClr val="tx1"/>
+        </a:solidFill>
+        <a:latin typeface="+mn-lt"/>
+        <a:ea typeface="+mn-ea"/>
+        <a:cs typeface="+mn-cs"/>
+      </a:defRPr>
+    </a:lvl1pPr>
+    <a:lvl2pPr marL="457200" algn="r" defTabSz="914400" rtl="1" eaLnBrk="1" latinLnBrk="0" hangingPunct="1">
+      <a:defRPr sz="1200" kern="1200">
+        <a:solidFill>
+          <a:schemeClr val="tx1"/>
+        </a:solidFill>
+        <a:latin typeface="+mn-lt"/>
+        <a:ea typeface="+mn-ea"/>
+        <a:cs typeface="+mn-cs"/>
+      </a:defRPr>
+    </a:lvl2pPr>
+    <a:lvl3pPr marL="914400" algn="r" defTabSz="914400" rtl="1" eaLnBrk="1" latinLnBrk="0" hangingPunct="1">
+      <a:defRPr sz="1200" kern="1200">
+        <a:solidFill>
+          <a:schemeClr val="tx1"/>
+        </a:solidFill>
+        <a:latin typeface="+mn-lt"/>
+        <a:ea typeface="+mn-ea"/>
+        <a:cs typeface="+mn-cs"/>
+      </a:defRPr>
+    </a:lvl3pPr>
+    <a:lvl4pPr marL="1371600" algn="r" defTabSz="914400" rtl="1" eaLnBrk="1" latinLnBrk="0" hangingPunct="1">
+      <a:defRPr sz="1200" kern="1200">
+        <a:solidFill>
+          <a:schemeClr val="tx1"/>
+        </a:solidFill>
+        <a:latin typeface="+mn-lt"/>
+        <a:ea typeface="+mn-ea"/>
+        <a:cs typeface="+mn-cs"/>
+      </a:defRPr>
+    </a:lvl4pPr>
+    <a:lvl5pPr marL="1828800" algn="r" defTabSz="914400" rtl="1" eaLnBrk="1" latinLnBrk="0" hangingPunct="1">
+      <a:defRPr sz="1200" kern="1200">
+        <a:solidFill>
+          <a:schemeClr val="tx1"/>
+        </a:solidFill>
+        <a:latin typeface="+mn-lt"/>
+        <a:ea typeface="+mn-ea"/>
+        <a:cs typeface="+mn-cs"/>
+      </a:defRPr>
+    </a:lvl5pPr>
+    <a:lvl6pPr marL="2286000" algn="r" defTabSz="914400" rtl="1" eaLnBrk="1" latinLnBrk="0" hangingPunct="1">
+      <a:defRPr sz="1200" kern="1200">
+        <a:solidFill>
+          <a:schemeClr val="tx1"/>
+        </a:solidFill>
+        <a:latin typeface="+mn-lt"/>
+        <a:ea typeface="+mn-ea"/>
+        <a:cs typeface="+mn-cs"/>
+      </a:defRPr>
+    </a:lvl6pPr>
+    <a:lvl7pPr marL="2743200" algn="r" defTabSz="914400" rtl="1" eaLnBrk="1" latinLnBrk="0" hangingPunct="1">
+      <a:defRPr sz="1200" kern="1200">
+        <a:solidFill>
+          <a:schemeClr val="tx1"/>
+        </a:solidFill>
+        <a:latin typeface="+mn-lt"/>
+        <a:ea typeface="+mn-ea"/>
+        <a:cs typeface="+mn-cs"/>
+      </a:defRPr>
+    </a:lvl7pPr>
+    <a:lvl8pPr marL="3200400" algn="r" defTabSz="914400" rtl="1" eaLnBrk="1" latinLnBrk="0" hangingPunct="1">
+      <a:defRPr sz="1200" kern="1200">
+        <a:solidFill>
+          <a:schemeClr val="tx1"/>
+        </a:solidFill>
+        <a:latin typeface="+mn-lt"/>
+        <a:ea typeface="+mn-ea"/>
+        <a:cs typeface="+mn-cs"/>
+      </a:defRPr>
+    </a:lvl8pPr>
+    <a:lvl9pPr marL="3657600" algn="r" defTabSz="914400" rtl="1" eaLnBrk="1" latinLnBrk="0" hangingPunct="1">
+      <a:defRPr sz="1200" kern="1200">
+        <a:solidFill>
+          <a:schemeClr val="tx1"/>
+        </a:solidFill>
+        <a:latin typeface="+mn-lt"/>
+        <a:ea typeface="+mn-ea"/>
+        <a:cs typeface="+mn-cs"/>
+      </a:defRPr>
+    </a:lvl9pPr>
+  </p:notesStyle>
+</p:notesMaster>
+</file>
+
+<file path=ppt/notesSlides/notesSlide1.xml><?xml version="1.0" encoding="utf-8"?>
+<p:notes xmlns:a="http://schemas.openxmlformats.org/drawingml/2006/main" xmlns:r="http://schemas.openxmlformats.org/officeDocument/2006/relationships" xmlns:p="http://schemas.openxmlformats.org/presentationml/2006/main">
+  <p:cSld>
+    <p:spTree>
+      <p:nvGrpSpPr>
+        <p:cNvPr id="1" name=""/>
+        <p:cNvGrpSpPr/>
+        <p:nvPr/>
+      </p:nvGrpSpPr>
+      <p:grpSpPr>
+        <a:xfrm>
+          <a:off x="0" y="0"/>
+          <a:ext cx="0" cy="0"/>
+          <a:chOff x="0" y="0"/>
+          <a:chExt cx="0" cy="0"/>
+        </a:xfrm>
+      </p:grpSpPr>
+      <p:sp>
+        <p:nvSpPr>
+          <p:cNvPr id="2" name="מציין מיקום של תמונת שקופית 1"/>
+          <p:cNvSpPr>
+            <a:spLocks noGrp="1" noRot="1" noChangeAspect="1"/>
+          </p:cNvSpPr>
+          <p:nvPr>
+            <p:ph type="sldImg"/>
+          </p:nvPr>
+        </p:nvSpPr>
+        <p:spPr/>
+      </p:sp>
+      <p:sp>
+        <p:nvSpPr>
+          <p:cNvPr id="3" name="מציין מיקום של הערות 2"/>
+          <p:cNvSpPr>
+            <a:spLocks noGrp="1"/>
+          </p:cNvSpPr>
+          <p:nvPr>
+            <p:ph type="body" idx="1"/>
+          </p:nvPr>
+        </p:nvSpPr>
+        <p:spPr/>
+        <p:txBody>
+          <a:bodyPr/>
+          <a:lstStyle/>
+          <a:p>
+            <a:r>
+              <a:rPr lang="he-IL" dirty="0"/>
+              <a:t>אולי לאחד את טבלת רעיונות עם טבלת הודעות ?</a:t>
+            </a:r>
+          </a:p>
+        </p:txBody>
+      </p:sp>
+      <p:sp>
+        <p:nvSpPr>
+          <p:cNvPr id="4" name="מציין מיקום של מספר שקופית 3"/>
+          <p:cNvSpPr>
+            <a:spLocks noGrp="1"/>
+          </p:cNvSpPr>
+          <p:nvPr>
+            <p:ph type="sldNum" sz="quarter" idx="5"/>
+          </p:nvPr>
+        </p:nvSpPr>
+        <p:spPr/>
+        <p:txBody>
+          <a:bodyPr/>
+          <a:lstStyle/>
+          <a:p>
+            <a:fld id="{8060B56F-2397-451C-B624-2F02EEC03C5E}" type="slidenum">
+              <a:rPr lang="he-IL" smtClean="0"/>
+              <a:t>12</a:t>
+            </a:fld>
+            <a:endParaRPr lang="he-IL"/>
+          </a:p>
+        </p:txBody>
+      </p:sp>
+    </p:spTree>
+    <p:extLst>
+      <p:ext uri="{BB962C8B-B14F-4D97-AF65-F5344CB8AC3E}">
+        <p14:creationId xmlns:p14="http://schemas.microsoft.com/office/powerpoint/2010/main" val="4293141936"/>
+      </p:ext>
+    </p:extLst>
+  </p:cSld>
+  <p:clrMapOvr>
+    <a:masterClrMapping/>
+  </p:clrMapOvr>
+</p:notes>
+</file>
+
 <file path=ppt/slideLayouts/slideLayout1.xml><?xml version="1.0" encoding="utf-8"?>
 <p:sldLayout xmlns:a="http://schemas.openxmlformats.org/drawingml/2006/main" xmlns:r="http://schemas.openxmlformats.org/officeDocument/2006/relationships" xmlns:p="http://schemas.openxmlformats.org/presentationml/2006/main" type="title" preserve="1">
   <p:cSld name="שקופית כותרת">
@@ -261,7 +720,7 @@
           <a:p>
             <a:fld id="{A13B40DE-C2A9-41DE-88C9-DFA4BEE0455F}" type="datetimeFigureOut">
               <a:rPr lang="he-IL" smtClean="0"/>
-              <a:t>כ"ד/כסלו/תשפ"ו</a:t>
+              <a:t>ט"ז/שבט/תשפ"ו</a:t>
             </a:fld>
             <a:endParaRPr lang="he-IL"/>
           </a:p>
@@ -459,7 +918,7 @@
           <a:p>
             <a:fld id="{A13B40DE-C2A9-41DE-88C9-DFA4BEE0455F}" type="datetimeFigureOut">
               <a:rPr lang="he-IL" smtClean="0"/>
-              <a:t>כ"ד/כסלו/תשפ"ו</a:t>
+              <a:t>ט"ז/שבט/תשפ"ו</a:t>
             </a:fld>
             <a:endParaRPr lang="he-IL"/>
           </a:p>
@@ -667,7 +1126,7 @@
           <a:p>
             <a:fld id="{A13B40DE-C2A9-41DE-88C9-DFA4BEE0455F}" type="datetimeFigureOut">
               <a:rPr lang="he-IL" smtClean="0"/>
-              <a:t>כ"ד/כסלו/תשפ"ו</a:t>
+              <a:t>ט"ז/שבט/תשפ"ו</a:t>
             </a:fld>
             <a:endParaRPr lang="he-IL"/>
           </a:p>
@@ -865,7 +1324,7 @@
           <a:p>
             <a:fld id="{A13B40DE-C2A9-41DE-88C9-DFA4BEE0455F}" type="datetimeFigureOut">
               <a:rPr lang="he-IL" smtClean="0"/>
-              <a:t>כ"ד/כסלו/תשפ"ו</a:t>
+              <a:t>ט"ז/שבט/תשפ"ו</a:t>
             </a:fld>
             <a:endParaRPr lang="he-IL"/>
           </a:p>
@@ -1140,7 +1599,7 @@
           <a:p>
             <a:fld id="{A13B40DE-C2A9-41DE-88C9-DFA4BEE0455F}" type="datetimeFigureOut">
               <a:rPr lang="he-IL" smtClean="0"/>
-              <a:t>כ"ד/כסלו/תשפ"ו</a:t>
+              <a:t>ט"ז/שבט/תשפ"ו</a:t>
             </a:fld>
             <a:endParaRPr lang="he-IL"/>
           </a:p>
@@ -1405,7 +1864,7 @@
           <a:p>
             <a:fld id="{A13B40DE-C2A9-41DE-88C9-DFA4BEE0455F}" type="datetimeFigureOut">
               <a:rPr lang="he-IL" smtClean="0"/>
-              <a:t>כ"ד/כסלו/תשפ"ו</a:t>
+              <a:t>ט"ז/שבט/תשפ"ו</a:t>
             </a:fld>
             <a:endParaRPr lang="he-IL"/>
           </a:p>
@@ -1817,7 +2276,7 @@
           <a:p>
             <a:fld id="{A13B40DE-C2A9-41DE-88C9-DFA4BEE0455F}" type="datetimeFigureOut">
               <a:rPr lang="he-IL" smtClean="0"/>
-              <a:t>כ"ד/כסלו/תשפ"ו</a:t>
+              <a:t>ט"ז/שבט/תשפ"ו</a:t>
             </a:fld>
             <a:endParaRPr lang="he-IL"/>
           </a:p>
@@ -1958,7 +2417,7 @@
           <a:p>
             <a:fld id="{A13B40DE-C2A9-41DE-88C9-DFA4BEE0455F}" type="datetimeFigureOut">
               <a:rPr lang="he-IL" smtClean="0"/>
-              <a:t>כ"ד/כסלו/תשפ"ו</a:t>
+              <a:t>ט"ז/שבט/תשפ"ו</a:t>
             </a:fld>
             <a:endParaRPr lang="he-IL"/>
           </a:p>
@@ -2071,7 +2530,7 @@
           <a:p>
             <a:fld id="{A13B40DE-C2A9-41DE-88C9-DFA4BEE0455F}" type="datetimeFigureOut">
               <a:rPr lang="he-IL" smtClean="0"/>
-              <a:t>כ"ד/כסלו/תשפ"ו</a:t>
+              <a:t>ט"ז/שבט/תשפ"ו</a:t>
             </a:fld>
             <a:endParaRPr lang="he-IL"/>
           </a:p>
@@ -2382,7 +2841,7 @@
           <a:p>
             <a:fld id="{A13B40DE-C2A9-41DE-88C9-DFA4BEE0455F}" type="datetimeFigureOut">
               <a:rPr lang="he-IL" smtClean="0"/>
-              <a:t>כ"ד/כסלו/תשפ"ו</a:t>
+              <a:t>ט"ז/שבט/תשפ"ו</a:t>
             </a:fld>
             <a:endParaRPr lang="he-IL"/>
           </a:p>
@@ -2670,7 +3129,7 @@
           <a:p>
             <a:fld id="{A13B40DE-C2A9-41DE-88C9-DFA4BEE0455F}" type="datetimeFigureOut">
               <a:rPr lang="he-IL" smtClean="0"/>
-              <a:t>כ"ד/כסלו/תשפ"ו</a:t>
+              <a:t>ט"ז/שבט/תשפ"ו</a:t>
             </a:fld>
             <a:endParaRPr lang="he-IL"/>
           </a:p>
@@ -2911,7 +3370,7 @@
           <a:p>
             <a:fld id="{A13B40DE-C2A9-41DE-88C9-DFA4BEE0455F}" type="datetimeFigureOut">
               <a:rPr lang="he-IL" smtClean="0"/>
-              <a:t>כ"ד/כסלו/תשפ"ו</a:t>
+              <a:t>ט"ז/שבט/תשפ"ו</a:t>
             </a:fld>
             <a:endParaRPr lang="he-IL"/>
           </a:p>
@@ -3351,7 +3810,7 @@
           <a:p>
             <a:r>
               <a:rPr lang="he-IL" dirty="0"/>
-              <a:t>פרויקט עיצוב התנהגות</a:t>
+              <a:t>פרויקט עיצוב התנהגות - לשם שינוי </a:t>
             </a:r>
           </a:p>
         </p:txBody>
@@ -3518,7 +3977,7 @@
                 <a:latin typeface="Bradley Hand ITC" panose="03070402050302030203" pitchFamily="66" charset="0"/>
                 <a:cs typeface="Guttman Yad-Brush" panose="02010401010101010101" pitchFamily="2" charset="-79"/>
               </a:rPr>
-              <a:t>10/12/25</a:t>
+              <a:t>22/01/2026</a:t>
             </a:r>
             <a:endParaRPr lang="he-IL" sz="4000" dirty="0">
               <a:ln w="0"/>
@@ -3539,6 +3998,1103 @@
     <p:extLst>
       <p:ext uri="{BB962C8B-B14F-4D97-AF65-F5344CB8AC3E}">
         <p14:creationId xmlns:p14="http://schemas.microsoft.com/office/powerpoint/2010/main" val="305270052"/>
+      </p:ext>
+    </p:extLst>
+  </p:cSld>
+  <p:clrMapOvr>
+    <a:masterClrMapping/>
+  </p:clrMapOvr>
+</p:sld>
+</file>
+
+<file path=ppt/slides/slide10.xml><?xml version="1.0" encoding="utf-8"?>
+<p:sld xmlns:a="http://schemas.openxmlformats.org/drawingml/2006/main" xmlns:r="http://schemas.openxmlformats.org/officeDocument/2006/relationships" xmlns:p="http://schemas.openxmlformats.org/presentationml/2006/main">
+  <p:cSld>
+    <p:spTree>
+      <p:nvGrpSpPr>
+        <p:cNvPr id="1" name=""/>
+        <p:cNvGrpSpPr/>
+        <p:nvPr/>
+      </p:nvGrpSpPr>
+      <p:grpSpPr>
+        <a:xfrm>
+          <a:off x="0" y="0"/>
+          <a:ext cx="0" cy="0"/>
+          <a:chOff x="0" y="0"/>
+          <a:chExt cx="0" cy="0"/>
+        </a:xfrm>
+      </p:grpSpPr>
+      <p:sp>
+        <p:nvSpPr>
+          <p:cNvPr id="2" name="כותרת 1">
+            <a:extLst>
+              <a:ext uri="{FF2B5EF4-FFF2-40B4-BE49-F238E27FC236}">
+                <a16:creationId xmlns:a16="http://schemas.microsoft.com/office/drawing/2014/main" id="{E75D3B03-CC4D-1D5B-BC4E-D3B2C8BFE1F4}"/>
+              </a:ext>
+            </a:extLst>
+          </p:cNvPr>
+          <p:cNvSpPr>
+            <a:spLocks noGrp="1"/>
+          </p:cNvSpPr>
+          <p:nvPr>
+            <p:ph type="title"/>
+          </p:nvPr>
+        </p:nvSpPr>
+        <p:spPr/>
+        <p:txBody>
+          <a:bodyPr/>
+          <a:lstStyle/>
+          <a:p>
+            <a:r>
+              <a:rPr lang="he-IL" dirty="0"/>
+              <a:t>מנגנון הצטיינות שבועית </a:t>
+            </a:r>
+          </a:p>
+        </p:txBody>
+      </p:sp>
+      <p:sp>
+        <p:nvSpPr>
+          <p:cNvPr id="3" name="מציין מיקום תוכן 2">
+            <a:extLst>
+              <a:ext uri="{FF2B5EF4-FFF2-40B4-BE49-F238E27FC236}">
+                <a16:creationId xmlns:a16="http://schemas.microsoft.com/office/drawing/2014/main" id="{B4B69D8D-B765-7946-566F-262CB28E9E8F}"/>
+              </a:ext>
+            </a:extLst>
+          </p:cNvPr>
+          <p:cNvSpPr>
+            <a:spLocks noGrp="1"/>
+          </p:cNvSpPr>
+          <p:nvPr>
+            <p:ph idx="1"/>
+          </p:nvPr>
+        </p:nvSpPr>
+        <p:spPr/>
+        <p:txBody>
+          <a:bodyPr/>
+          <a:lstStyle/>
+          <a:p>
+            <a:r>
+              <a:rPr lang="he-IL" dirty="0"/>
+              <a:t>קריטריונים – כל מורה קובעת לכיתתה (או לתלמידה) סף הצטיינות בנקודות הסף לא נקבע במערכת בשל הרגישות והשינויים התדירים בסף הכיתה והשינויים בסף עבור כל תלמידה בנפרד</a:t>
+            </a:r>
+          </a:p>
+          <a:p>
+            <a:r>
+              <a:rPr lang="he-IL" dirty="0"/>
+              <a:t>מגבלות זמן – יש לעדכן הצטיינות מיום שישי בשעה 08:00 ועד יום ראשון בשעה 10:00</a:t>
+            </a:r>
+          </a:p>
+          <a:p>
+            <a:r>
+              <a:rPr lang="he-IL" dirty="0"/>
+              <a:t>חישוב אוטומטי – של הצטיינות חודשית (5 תעודות מתוך 6 או 4 מתוך 5 תלוי כמה שבועות יש בתקופת ההצטיינות שהגדירו)</a:t>
+            </a:r>
+          </a:p>
+          <a:p>
+            <a:r>
+              <a:rPr lang="he-IL" dirty="0"/>
+              <a:t>תעודות ושוברים – השוברים למימוש בקיוסק התעודות למפת הדרך להצטיינות החודשית</a:t>
+            </a:r>
+          </a:p>
+          <a:p>
+            <a:endParaRPr lang="he-IL" dirty="0"/>
+          </a:p>
+        </p:txBody>
+      </p:sp>
+    </p:spTree>
+    <p:extLst>
+      <p:ext uri="{BB962C8B-B14F-4D97-AF65-F5344CB8AC3E}">
+        <p14:creationId xmlns:p14="http://schemas.microsoft.com/office/powerpoint/2010/main" val="1216514904"/>
+      </p:ext>
+    </p:extLst>
+  </p:cSld>
+  <p:clrMapOvr>
+    <a:masterClrMapping/>
+  </p:clrMapOvr>
+</p:sld>
+</file>
+
+<file path=ppt/slides/slide11.xml><?xml version="1.0" encoding="utf-8"?>
+<p:sld xmlns:a="http://schemas.openxmlformats.org/drawingml/2006/main" xmlns:r="http://schemas.openxmlformats.org/officeDocument/2006/relationships" xmlns:p="http://schemas.openxmlformats.org/presentationml/2006/main">
+  <p:cSld>
+    <p:spTree>
+      <p:nvGrpSpPr>
+        <p:cNvPr id="1" name=""/>
+        <p:cNvGrpSpPr/>
+        <p:nvPr/>
+      </p:nvGrpSpPr>
+      <p:grpSpPr>
+        <a:xfrm>
+          <a:off x="0" y="0"/>
+          <a:ext cx="0" cy="0"/>
+          <a:chOff x="0" y="0"/>
+          <a:chExt cx="0" cy="0"/>
+        </a:xfrm>
+      </p:grpSpPr>
+      <p:sp>
+        <p:nvSpPr>
+          <p:cNvPr id="2" name="כותרת 1">
+            <a:extLst>
+              <a:ext uri="{FF2B5EF4-FFF2-40B4-BE49-F238E27FC236}">
+                <a16:creationId xmlns:a16="http://schemas.microsoft.com/office/drawing/2014/main" id="{349A88EC-E807-A7A8-C046-F209FDAAEFD3}"/>
+              </a:ext>
+            </a:extLst>
+          </p:cNvPr>
+          <p:cNvSpPr>
+            <a:spLocks noGrp="1"/>
+          </p:cNvSpPr>
+          <p:nvPr>
+            <p:ph type="title"/>
+          </p:nvPr>
+        </p:nvSpPr>
+        <p:spPr/>
+        <p:txBody>
+          <a:bodyPr/>
+          <a:lstStyle/>
+          <a:p>
+            <a:r>
+              <a:rPr lang="he-IL" dirty="0"/>
+              <a:t>גרפים ומעקב התקדמות </a:t>
+            </a:r>
+          </a:p>
+        </p:txBody>
+      </p:sp>
+      <p:sp>
+        <p:nvSpPr>
+          <p:cNvPr id="3" name="מציין מיקום תוכן 2">
+            <a:extLst>
+              <a:ext uri="{FF2B5EF4-FFF2-40B4-BE49-F238E27FC236}">
+                <a16:creationId xmlns:a16="http://schemas.microsoft.com/office/drawing/2014/main" id="{016EB8E6-8D4F-36CE-A91A-A698A140C090}"/>
+              </a:ext>
+            </a:extLst>
+          </p:cNvPr>
+          <p:cNvSpPr>
+            <a:spLocks noGrp="1"/>
+          </p:cNvSpPr>
+          <p:nvPr>
+            <p:ph idx="1"/>
+          </p:nvPr>
+        </p:nvSpPr>
+        <p:spPr/>
+        <p:txBody>
+          <a:bodyPr/>
+          <a:lstStyle/>
+          <a:p>
+            <a:r>
+              <a:rPr lang="he-IL" dirty="0"/>
+              <a:t>גרפים לתלמידה </a:t>
+            </a:r>
+          </a:p>
+          <a:p>
+            <a:r>
+              <a:rPr lang="he-IL" dirty="0"/>
+              <a:t>גרפים למורה – כולל אפשרות צפיה בגרפי התלמידות שלה</a:t>
+            </a:r>
+          </a:p>
+          <a:p>
+            <a:r>
+              <a:rPr lang="he-IL" dirty="0"/>
+              <a:t>גרפים לצוות ניהולי וטיפולי – כולל אפשרות </a:t>
+            </a:r>
+            <a:r>
+              <a:rPr lang="he-IL" dirty="0" err="1"/>
+              <a:t>לצפיה</a:t>
+            </a:r>
+            <a:r>
+              <a:rPr lang="he-IL" dirty="0"/>
+              <a:t> בכל גרפי מורה ותלמידה + אפשרות צפיה בגרפי התיכון כולו</a:t>
+            </a:r>
+          </a:p>
+          <a:p>
+            <a:endParaRPr lang="he-IL" dirty="0"/>
+          </a:p>
+        </p:txBody>
+      </p:sp>
+    </p:spTree>
+    <p:extLst>
+      <p:ext uri="{BB962C8B-B14F-4D97-AF65-F5344CB8AC3E}">
+        <p14:creationId xmlns:p14="http://schemas.microsoft.com/office/powerpoint/2010/main" val="3303662313"/>
+      </p:ext>
+    </p:extLst>
+  </p:cSld>
+  <p:clrMapOvr>
+    <a:masterClrMapping/>
+  </p:clrMapOvr>
+</p:sld>
+</file>
+
+<file path=ppt/slides/slide12.xml><?xml version="1.0" encoding="utf-8"?>
+<p:sld xmlns:a="http://schemas.openxmlformats.org/drawingml/2006/main" xmlns:r="http://schemas.openxmlformats.org/officeDocument/2006/relationships" xmlns:p="http://schemas.openxmlformats.org/presentationml/2006/main">
+  <p:cSld>
+    <p:spTree>
+      <p:nvGrpSpPr>
+        <p:cNvPr id="1" name=""/>
+        <p:cNvGrpSpPr/>
+        <p:nvPr/>
+      </p:nvGrpSpPr>
+      <p:grpSpPr>
+        <a:xfrm>
+          <a:off x="0" y="0"/>
+          <a:ext cx="0" cy="0"/>
+          <a:chOff x="0" y="0"/>
+          <a:chExt cx="0" cy="0"/>
+        </a:xfrm>
+      </p:grpSpPr>
+      <p:sp>
+        <p:nvSpPr>
+          <p:cNvPr id="2" name="כותרת 1">
+            <a:extLst>
+              <a:ext uri="{FF2B5EF4-FFF2-40B4-BE49-F238E27FC236}">
+                <a16:creationId xmlns:a16="http://schemas.microsoft.com/office/drawing/2014/main" id="{05628BE9-112D-DA4D-F04A-6AFB624D398D}"/>
+              </a:ext>
+            </a:extLst>
+          </p:cNvPr>
+          <p:cNvSpPr>
+            <a:spLocks noGrp="1"/>
+          </p:cNvSpPr>
+          <p:nvPr>
+            <p:ph type="title"/>
+          </p:nvPr>
+        </p:nvSpPr>
+        <p:spPr/>
+        <p:txBody>
+          <a:bodyPr/>
+          <a:lstStyle/>
+          <a:p>
+            <a:r>
+              <a:rPr lang="he-IL" dirty="0"/>
+              <a:t>מערכת הודעות והערות </a:t>
+            </a:r>
+          </a:p>
+        </p:txBody>
+      </p:sp>
+      <p:sp>
+        <p:nvSpPr>
+          <p:cNvPr id="3" name="מציין מיקום תוכן 2">
+            <a:extLst>
+              <a:ext uri="{FF2B5EF4-FFF2-40B4-BE49-F238E27FC236}">
+                <a16:creationId xmlns:a16="http://schemas.microsoft.com/office/drawing/2014/main" id="{7B97840C-A92E-11E2-3CF5-A4729FAB9986}"/>
+              </a:ext>
+            </a:extLst>
+          </p:cNvPr>
+          <p:cNvSpPr>
+            <a:spLocks noGrp="1"/>
+          </p:cNvSpPr>
+          <p:nvPr>
+            <p:ph idx="1"/>
+          </p:nvPr>
+        </p:nvSpPr>
+        <p:spPr/>
+        <p:txBody>
+          <a:bodyPr/>
+          <a:lstStyle/>
+          <a:p>
+            <a:r>
+              <a:rPr lang="he-IL" dirty="0"/>
+              <a:t>הודעות מורה (לתלמידה)</a:t>
+            </a:r>
+          </a:p>
+          <a:p>
+            <a:r>
+              <a:rPr lang="he-IL" dirty="0"/>
+              <a:t>הודעות צוות (טיפולי וניהולי), (לתלמידה)</a:t>
+            </a:r>
+          </a:p>
+          <a:p>
+            <a:r>
+              <a:rPr lang="he-IL" dirty="0"/>
+              <a:t>הודעות תלמידות (לצוות ניהול המערכת)</a:t>
+            </a:r>
+          </a:p>
+          <a:p>
+            <a:r>
+              <a:rPr lang="he-IL" dirty="0"/>
+              <a:t>היסטורית תקשורת </a:t>
+            </a:r>
+          </a:p>
+        </p:txBody>
+      </p:sp>
+    </p:spTree>
+    <p:extLst>
+      <p:ext uri="{BB962C8B-B14F-4D97-AF65-F5344CB8AC3E}">
+        <p14:creationId xmlns:p14="http://schemas.microsoft.com/office/powerpoint/2010/main" val="1156942351"/>
+      </p:ext>
+    </p:extLst>
+  </p:cSld>
+  <p:clrMapOvr>
+    <a:masterClrMapping/>
+  </p:clrMapOvr>
+</p:sld>
+</file>
+
+<file path=ppt/slides/slide13.xml><?xml version="1.0" encoding="utf-8"?>
+<p:sld xmlns:a="http://schemas.openxmlformats.org/drawingml/2006/main" xmlns:r="http://schemas.openxmlformats.org/officeDocument/2006/relationships" xmlns:p="http://schemas.openxmlformats.org/presentationml/2006/main">
+  <p:cSld>
+    <p:spTree>
+      <p:nvGrpSpPr>
+        <p:cNvPr id="1" name=""/>
+        <p:cNvGrpSpPr/>
+        <p:nvPr/>
+      </p:nvGrpSpPr>
+      <p:grpSpPr>
+        <a:xfrm>
+          <a:off x="0" y="0"/>
+          <a:ext cx="0" cy="0"/>
+          <a:chOff x="0" y="0"/>
+          <a:chExt cx="0" cy="0"/>
+        </a:xfrm>
+      </p:grpSpPr>
+      <p:sp>
+        <p:nvSpPr>
+          <p:cNvPr id="2" name="כותרת 1">
+            <a:extLst>
+              <a:ext uri="{FF2B5EF4-FFF2-40B4-BE49-F238E27FC236}">
+                <a16:creationId xmlns:a16="http://schemas.microsoft.com/office/drawing/2014/main" id="{D7FF597F-DEE2-83A1-2E2E-BD3BB2500478}"/>
+              </a:ext>
+            </a:extLst>
+          </p:cNvPr>
+          <p:cNvSpPr>
+            <a:spLocks noGrp="1"/>
+          </p:cNvSpPr>
+          <p:nvPr>
+            <p:ph type="title"/>
+          </p:nvPr>
+        </p:nvSpPr>
+        <p:spPr/>
+        <p:txBody>
+          <a:bodyPr/>
+          <a:lstStyle/>
+          <a:p>
+            <a:r>
+              <a:rPr lang="he-IL" dirty="0"/>
+              <a:t>מסד נתונים </a:t>
+            </a:r>
+            <a:r>
+              <a:rPr lang="en-US" dirty="0"/>
+              <a:t>DB</a:t>
+            </a:r>
+            <a:r>
+              <a:rPr lang="he-IL" dirty="0"/>
+              <a:t> – מבנה ועקרונות </a:t>
+            </a:r>
+          </a:p>
+        </p:txBody>
+      </p:sp>
+      <p:sp>
+        <p:nvSpPr>
+          <p:cNvPr id="3" name="מציין מיקום תוכן 2">
+            <a:extLst>
+              <a:ext uri="{FF2B5EF4-FFF2-40B4-BE49-F238E27FC236}">
+                <a16:creationId xmlns:a16="http://schemas.microsoft.com/office/drawing/2014/main" id="{81D98507-6CC7-BA9F-7A37-415BA1D39E4D}"/>
+              </a:ext>
+            </a:extLst>
+          </p:cNvPr>
+          <p:cNvSpPr>
+            <a:spLocks noGrp="1"/>
+          </p:cNvSpPr>
+          <p:nvPr>
+            <p:ph idx="1"/>
+          </p:nvPr>
+        </p:nvSpPr>
+        <p:spPr/>
+        <p:txBody>
+          <a:bodyPr/>
+          <a:lstStyle/>
+          <a:p>
+            <a:r>
+              <a:rPr lang="en-US" dirty="0"/>
+              <a:t>MongoDB</a:t>
+            </a:r>
+          </a:p>
+          <a:p>
+            <a:r>
+              <a:rPr lang="en-US" dirty="0"/>
+              <a:t>Collections</a:t>
+            </a:r>
+          </a:p>
+          <a:p>
+            <a:r>
+              <a:rPr lang="he-IL" dirty="0"/>
+              <a:t>קשרים בין ישויות </a:t>
+            </a:r>
+          </a:p>
+          <a:p>
+            <a:r>
+              <a:rPr lang="he-IL" dirty="0"/>
+              <a:t>תמיכה בהתרחבות עתידית</a:t>
+            </a:r>
+          </a:p>
+        </p:txBody>
+      </p:sp>
+    </p:spTree>
+    <p:extLst>
+      <p:ext uri="{BB962C8B-B14F-4D97-AF65-F5344CB8AC3E}">
+        <p14:creationId xmlns:p14="http://schemas.microsoft.com/office/powerpoint/2010/main" val="208521521"/>
+      </p:ext>
+    </p:extLst>
+  </p:cSld>
+  <p:clrMapOvr>
+    <a:masterClrMapping/>
+  </p:clrMapOvr>
+</p:sld>
+</file>
+
+<file path=ppt/slides/slide14.xml><?xml version="1.0" encoding="utf-8"?>
+<p:sld xmlns:a="http://schemas.openxmlformats.org/drawingml/2006/main" xmlns:r="http://schemas.openxmlformats.org/officeDocument/2006/relationships" xmlns:p="http://schemas.openxmlformats.org/presentationml/2006/main">
+  <p:cSld>
+    <p:spTree>
+      <p:nvGrpSpPr>
+        <p:cNvPr id="1" name=""/>
+        <p:cNvGrpSpPr/>
+        <p:nvPr/>
+      </p:nvGrpSpPr>
+      <p:grpSpPr>
+        <a:xfrm>
+          <a:off x="0" y="0"/>
+          <a:ext cx="0" cy="0"/>
+          <a:chOff x="0" y="0"/>
+          <a:chExt cx="0" cy="0"/>
+        </a:xfrm>
+      </p:grpSpPr>
+      <p:sp>
+        <p:nvSpPr>
+          <p:cNvPr id="2" name="כותרת 1">
+            <a:extLst>
+              <a:ext uri="{FF2B5EF4-FFF2-40B4-BE49-F238E27FC236}">
+                <a16:creationId xmlns:a16="http://schemas.microsoft.com/office/drawing/2014/main" id="{7A89C01E-D45A-57E9-EEAD-12C666B74D62}"/>
+              </a:ext>
+            </a:extLst>
+          </p:cNvPr>
+          <p:cNvSpPr>
+            <a:spLocks noGrp="1"/>
+          </p:cNvSpPr>
+          <p:nvPr>
+            <p:ph type="title"/>
+          </p:nvPr>
+        </p:nvSpPr>
+        <p:spPr/>
+        <p:txBody>
+          <a:bodyPr/>
+          <a:lstStyle/>
+          <a:p>
+            <a:r>
+              <a:rPr lang="he-IL" dirty="0"/>
+              <a:t>הרשאות ותפקידי משתמשים </a:t>
+            </a:r>
+          </a:p>
+        </p:txBody>
+      </p:sp>
+      <p:sp>
+        <p:nvSpPr>
+          <p:cNvPr id="3" name="מציין מיקום תוכן 2">
+            <a:extLst>
+              <a:ext uri="{FF2B5EF4-FFF2-40B4-BE49-F238E27FC236}">
+                <a16:creationId xmlns:a16="http://schemas.microsoft.com/office/drawing/2014/main" id="{504015C3-99C0-5A4B-8F9E-682240798C79}"/>
+              </a:ext>
+            </a:extLst>
+          </p:cNvPr>
+          <p:cNvSpPr>
+            <a:spLocks noGrp="1"/>
+          </p:cNvSpPr>
+          <p:nvPr>
+            <p:ph idx="1"/>
+          </p:nvPr>
+        </p:nvSpPr>
+        <p:spPr/>
+        <p:txBody>
+          <a:bodyPr/>
+          <a:lstStyle/>
+          <a:p>
+            <a:r>
+              <a:rPr lang="en-US" dirty="0"/>
+              <a:t>Role-based access</a:t>
+            </a:r>
+          </a:p>
+          <a:p>
+            <a:r>
+              <a:rPr lang="he-IL" dirty="0"/>
+              <a:t>הבדלי הרשאות </a:t>
+            </a:r>
+          </a:p>
+          <a:p>
+            <a:r>
+              <a:rPr lang="he-IL" dirty="0"/>
+              <a:t>גישה מבוקרת לנתונים </a:t>
+            </a:r>
+          </a:p>
+        </p:txBody>
+      </p:sp>
+    </p:spTree>
+    <p:extLst>
+      <p:ext uri="{BB962C8B-B14F-4D97-AF65-F5344CB8AC3E}">
+        <p14:creationId xmlns:p14="http://schemas.microsoft.com/office/powerpoint/2010/main" val="3647440785"/>
+      </p:ext>
+    </p:extLst>
+  </p:cSld>
+  <p:clrMapOvr>
+    <a:masterClrMapping/>
+  </p:clrMapOvr>
+</p:sld>
+</file>
+
+<file path=ppt/slides/slide15.xml><?xml version="1.0" encoding="utf-8"?>
+<p:sld xmlns:a="http://schemas.openxmlformats.org/drawingml/2006/main" xmlns:r="http://schemas.openxmlformats.org/officeDocument/2006/relationships" xmlns:p="http://schemas.openxmlformats.org/presentationml/2006/main">
+  <p:cSld>
+    <p:spTree>
+      <p:nvGrpSpPr>
+        <p:cNvPr id="1" name=""/>
+        <p:cNvGrpSpPr/>
+        <p:nvPr/>
+      </p:nvGrpSpPr>
+      <p:grpSpPr>
+        <a:xfrm>
+          <a:off x="0" y="0"/>
+          <a:ext cx="0" cy="0"/>
+          <a:chOff x="0" y="0"/>
+          <a:chExt cx="0" cy="0"/>
+        </a:xfrm>
+      </p:grpSpPr>
+      <p:sp>
+        <p:nvSpPr>
+          <p:cNvPr id="2" name="כותרת 1">
+            <a:extLst>
+              <a:ext uri="{FF2B5EF4-FFF2-40B4-BE49-F238E27FC236}">
+                <a16:creationId xmlns:a16="http://schemas.microsoft.com/office/drawing/2014/main" id="{54C4A1A2-3F08-67CE-A65D-A70CC658AAFB}"/>
+              </a:ext>
+            </a:extLst>
+          </p:cNvPr>
+          <p:cNvSpPr>
+            <a:spLocks noGrp="1"/>
+          </p:cNvSpPr>
+          <p:nvPr>
+            <p:ph type="title"/>
+          </p:nvPr>
+        </p:nvSpPr>
+        <p:spPr/>
+        <p:txBody>
+          <a:bodyPr/>
+          <a:lstStyle/>
+          <a:p>
+            <a:r>
+              <a:rPr lang="he-IL" dirty="0"/>
+              <a:t>חוקים עסקיים ולוגיקה מערכתית</a:t>
+            </a:r>
+          </a:p>
+        </p:txBody>
+      </p:sp>
+      <p:sp>
+        <p:nvSpPr>
+          <p:cNvPr id="3" name="מציין מיקום תוכן 2">
+            <a:extLst>
+              <a:ext uri="{FF2B5EF4-FFF2-40B4-BE49-F238E27FC236}">
+                <a16:creationId xmlns:a16="http://schemas.microsoft.com/office/drawing/2014/main" id="{94A3FB3A-5C3C-EE45-107B-7630041B9DD9}"/>
+              </a:ext>
+            </a:extLst>
+          </p:cNvPr>
+          <p:cNvSpPr>
+            <a:spLocks noGrp="1"/>
+          </p:cNvSpPr>
+          <p:nvPr>
+            <p:ph idx="1"/>
+          </p:nvPr>
+        </p:nvSpPr>
+        <p:spPr/>
+        <p:txBody>
+          <a:bodyPr/>
+          <a:lstStyle/>
+          <a:p>
+            <a:r>
+              <a:rPr lang="he-IL" dirty="0"/>
+              <a:t>בכל שבוע מחדש התלמידה צופה בנתוני השבוע הנוכחי בלבד</a:t>
+            </a:r>
+          </a:p>
+          <a:p>
+            <a:r>
+              <a:rPr lang="he-IL" dirty="0"/>
+              <a:t>חישובי נקודות</a:t>
+            </a:r>
+          </a:p>
+          <a:p>
+            <a:r>
+              <a:rPr lang="he-IL" dirty="0"/>
+              <a:t>חישובי שוברים </a:t>
+            </a:r>
+          </a:p>
+          <a:p>
+            <a:r>
+              <a:rPr lang="he-IL" dirty="0"/>
+              <a:t>כללי הצטיינות</a:t>
+            </a:r>
+          </a:p>
+          <a:p>
+            <a:r>
+              <a:rPr lang="he-IL" dirty="0"/>
+              <a:t>זמני פתיחה וסגירה של המערכת</a:t>
+            </a:r>
+          </a:p>
+          <a:p>
+            <a:endParaRPr lang="he-IL" dirty="0"/>
+          </a:p>
+        </p:txBody>
+      </p:sp>
+    </p:spTree>
+    <p:extLst>
+      <p:ext uri="{BB962C8B-B14F-4D97-AF65-F5344CB8AC3E}">
+        <p14:creationId xmlns:p14="http://schemas.microsoft.com/office/powerpoint/2010/main" val="4160007878"/>
+      </p:ext>
+    </p:extLst>
+  </p:cSld>
+  <p:clrMapOvr>
+    <a:masterClrMapping/>
+  </p:clrMapOvr>
+</p:sld>
+</file>
+
+<file path=ppt/slides/slide16.xml><?xml version="1.0" encoding="utf-8"?>
+<p:sld xmlns:a="http://schemas.openxmlformats.org/drawingml/2006/main" xmlns:r="http://schemas.openxmlformats.org/officeDocument/2006/relationships" xmlns:p="http://schemas.openxmlformats.org/presentationml/2006/main">
+  <p:cSld>
+    <p:spTree>
+      <p:nvGrpSpPr>
+        <p:cNvPr id="1" name=""/>
+        <p:cNvGrpSpPr/>
+        <p:nvPr/>
+      </p:nvGrpSpPr>
+      <p:grpSpPr>
+        <a:xfrm>
+          <a:off x="0" y="0"/>
+          <a:ext cx="0" cy="0"/>
+          <a:chOff x="0" y="0"/>
+          <a:chExt cx="0" cy="0"/>
+        </a:xfrm>
+      </p:grpSpPr>
+      <p:sp>
+        <p:nvSpPr>
+          <p:cNvPr id="2" name="כותרת 1">
+            <a:extLst>
+              <a:ext uri="{FF2B5EF4-FFF2-40B4-BE49-F238E27FC236}">
+                <a16:creationId xmlns:a16="http://schemas.microsoft.com/office/drawing/2014/main" id="{9AB79879-BD55-C1F2-C70D-AB922608AA0F}"/>
+              </a:ext>
+            </a:extLst>
+          </p:cNvPr>
+          <p:cNvSpPr>
+            <a:spLocks noGrp="1"/>
+          </p:cNvSpPr>
+          <p:nvPr>
+            <p:ph type="title"/>
+          </p:nvPr>
+        </p:nvSpPr>
+        <p:spPr/>
+        <p:txBody>
+          <a:bodyPr/>
+          <a:lstStyle/>
+          <a:p>
+            <a:r>
+              <a:rPr lang="he-IL" dirty="0"/>
+              <a:t>ארכיטקטורה טכנולוגית </a:t>
+            </a:r>
+          </a:p>
+        </p:txBody>
+      </p:sp>
+      <p:sp>
+        <p:nvSpPr>
+          <p:cNvPr id="3" name="מציין מיקום תוכן 2">
+            <a:extLst>
+              <a:ext uri="{FF2B5EF4-FFF2-40B4-BE49-F238E27FC236}">
+                <a16:creationId xmlns:a16="http://schemas.microsoft.com/office/drawing/2014/main" id="{59120DB9-8621-A432-32F1-7DB47ED1D94E}"/>
+              </a:ext>
+            </a:extLst>
+          </p:cNvPr>
+          <p:cNvSpPr>
+            <a:spLocks noGrp="1"/>
+          </p:cNvSpPr>
+          <p:nvPr>
+            <p:ph idx="1"/>
+          </p:nvPr>
+        </p:nvSpPr>
+        <p:spPr/>
+        <p:txBody>
+          <a:bodyPr/>
+          <a:lstStyle/>
+          <a:p>
+            <a:r>
+              <a:rPr lang="en-US" dirty="0"/>
+              <a:t>Frontend</a:t>
+            </a:r>
+          </a:p>
+          <a:p>
+            <a:r>
+              <a:rPr lang="en-US" dirty="0"/>
+              <a:t>Backend</a:t>
+            </a:r>
+          </a:p>
+          <a:p>
+            <a:r>
+              <a:rPr lang="en-US" dirty="0"/>
+              <a:t>DB</a:t>
+            </a:r>
+            <a:r>
+              <a:rPr lang="he-IL" dirty="0"/>
+              <a:t> </a:t>
+            </a:r>
+          </a:p>
+        </p:txBody>
+      </p:sp>
+    </p:spTree>
+    <p:extLst>
+      <p:ext uri="{BB962C8B-B14F-4D97-AF65-F5344CB8AC3E}">
+        <p14:creationId xmlns:p14="http://schemas.microsoft.com/office/powerpoint/2010/main" val="4048377017"/>
+      </p:ext>
+    </p:extLst>
+  </p:cSld>
+  <p:clrMapOvr>
+    <a:masterClrMapping/>
+  </p:clrMapOvr>
+</p:sld>
+</file>
+
+<file path=ppt/slides/slide17.xml><?xml version="1.0" encoding="utf-8"?>
+<p:sld xmlns:a="http://schemas.openxmlformats.org/drawingml/2006/main" xmlns:r="http://schemas.openxmlformats.org/officeDocument/2006/relationships" xmlns:p="http://schemas.openxmlformats.org/presentationml/2006/main">
+  <p:cSld>
+    <p:spTree>
+      <p:nvGrpSpPr>
+        <p:cNvPr id="1" name=""/>
+        <p:cNvGrpSpPr/>
+        <p:nvPr/>
+      </p:nvGrpSpPr>
+      <p:grpSpPr>
+        <a:xfrm>
+          <a:off x="0" y="0"/>
+          <a:ext cx="0" cy="0"/>
+          <a:chOff x="0" y="0"/>
+          <a:chExt cx="0" cy="0"/>
+        </a:xfrm>
+      </p:grpSpPr>
+      <p:sp>
+        <p:nvSpPr>
+          <p:cNvPr id="2" name="כותרת 1">
+            <a:extLst>
+              <a:ext uri="{FF2B5EF4-FFF2-40B4-BE49-F238E27FC236}">
+                <a16:creationId xmlns:a16="http://schemas.microsoft.com/office/drawing/2014/main" id="{DE505A82-451F-AB52-6A4C-6B92DA741B9D}"/>
+              </a:ext>
+            </a:extLst>
+          </p:cNvPr>
+          <p:cNvSpPr>
+            <a:spLocks noGrp="1"/>
+          </p:cNvSpPr>
+          <p:nvPr>
+            <p:ph type="title"/>
+          </p:nvPr>
+        </p:nvSpPr>
+        <p:spPr/>
+        <p:txBody>
+          <a:bodyPr/>
+          <a:lstStyle/>
+          <a:p>
+            <a:r>
+              <a:rPr lang="he-IL" dirty="0"/>
+              <a:t>תהליכים מרכזיים (</a:t>
+            </a:r>
+            <a:r>
+              <a:rPr lang="en-US" dirty="0"/>
+              <a:t>User Flows</a:t>
+            </a:r>
+            <a:r>
+              <a:rPr lang="he-IL" dirty="0"/>
+              <a:t>)</a:t>
+            </a:r>
+          </a:p>
+        </p:txBody>
+      </p:sp>
+      <p:sp>
+        <p:nvSpPr>
+          <p:cNvPr id="3" name="מציין מיקום תוכן 2">
+            <a:extLst>
+              <a:ext uri="{FF2B5EF4-FFF2-40B4-BE49-F238E27FC236}">
+                <a16:creationId xmlns:a16="http://schemas.microsoft.com/office/drawing/2014/main" id="{6819DD82-ED63-069A-36E9-0E019E019A2A}"/>
+              </a:ext>
+            </a:extLst>
+          </p:cNvPr>
+          <p:cNvSpPr>
+            <a:spLocks noGrp="1"/>
+          </p:cNvSpPr>
+          <p:nvPr>
+            <p:ph idx="1"/>
+          </p:nvPr>
+        </p:nvSpPr>
+        <p:spPr/>
+        <p:txBody>
+          <a:bodyPr/>
+          <a:lstStyle/>
+          <a:p>
+            <a:r>
+              <a:rPr lang="he-IL" dirty="0"/>
+              <a:t>הזנת נקודות יומית על כל שיעור ע"י מורה </a:t>
+            </a:r>
+          </a:p>
+          <a:p>
+            <a:r>
+              <a:rPr lang="he-IL" dirty="0"/>
+              <a:t>צבירת שוברים ותעודות לתלמידה ע"י עדכון המורה </a:t>
+            </a:r>
+          </a:p>
+          <a:p>
+            <a:r>
+              <a:rPr lang="he-IL" dirty="0"/>
+              <a:t>רכישה בקיוסק ע"י התלמידות</a:t>
+            </a:r>
+          </a:p>
+          <a:p>
+            <a:r>
+              <a:rPr lang="he-IL" dirty="0"/>
+              <a:t>שליחת הודעות לתלמידות ע"י מורה </a:t>
+            </a:r>
+          </a:p>
+          <a:p>
+            <a:r>
+              <a:rPr lang="he-IL" dirty="0"/>
+              <a:t>הצעת רעיונות ע"י התלמידות </a:t>
+            </a:r>
+          </a:p>
+          <a:p>
+            <a:r>
+              <a:rPr lang="he-IL" dirty="0"/>
+              <a:t>היסטוריה למורות </a:t>
+            </a:r>
+          </a:p>
+          <a:p>
+            <a:r>
+              <a:rPr lang="he-IL" dirty="0"/>
+              <a:t>ניתוח גרפים למורות לתלמידות ולצוות הניהולי והטיפולי</a:t>
+            </a:r>
+          </a:p>
+        </p:txBody>
+      </p:sp>
+    </p:spTree>
+    <p:extLst>
+      <p:ext uri="{BB962C8B-B14F-4D97-AF65-F5344CB8AC3E}">
+        <p14:creationId xmlns:p14="http://schemas.microsoft.com/office/powerpoint/2010/main" val="1795262041"/>
+      </p:ext>
+    </p:extLst>
+  </p:cSld>
+  <p:clrMapOvr>
+    <a:masterClrMapping/>
+  </p:clrMapOvr>
+</p:sld>
+</file>
+
+<file path=ppt/slides/slide18.xml><?xml version="1.0" encoding="utf-8"?>
+<p:sld xmlns:a="http://schemas.openxmlformats.org/drawingml/2006/main" xmlns:r="http://schemas.openxmlformats.org/officeDocument/2006/relationships" xmlns:p="http://schemas.openxmlformats.org/presentationml/2006/main">
+  <p:cSld>
+    <p:spTree>
+      <p:nvGrpSpPr>
+        <p:cNvPr id="1" name=""/>
+        <p:cNvGrpSpPr/>
+        <p:nvPr/>
+      </p:nvGrpSpPr>
+      <p:grpSpPr>
+        <a:xfrm>
+          <a:off x="0" y="0"/>
+          <a:ext cx="0" cy="0"/>
+          <a:chOff x="0" y="0"/>
+          <a:chExt cx="0" cy="0"/>
+        </a:xfrm>
+      </p:grpSpPr>
+      <p:sp>
+        <p:nvSpPr>
+          <p:cNvPr id="2" name="כותרת 1">
+            <a:extLst>
+              <a:ext uri="{FF2B5EF4-FFF2-40B4-BE49-F238E27FC236}">
+                <a16:creationId xmlns:a16="http://schemas.microsoft.com/office/drawing/2014/main" id="{7200C2F8-03CC-27BC-3D1F-1338320DECFD}"/>
+              </a:ext>
+            </a:extLst>
+          </p:cNvPr>
+          <p:cNvSpPr>
+            <a:spLocks noGrp="1"/>
+          </p:cNvSpPr>
+          <p:nvPr>
+            <p:ph type="title"/>
+          </p:nvPr>
+        </p:nvSpPr>
+        <p:spPr/>
+        <p:txBody>
+          <a:bodyPr/>
+          <a:lstStyle/>
+          <a:p>
+            <a:r>
+              <a:rPr lang="he-IL" dirty="0"/>
+              <a:t>שלבי פיתוח </a:t>
+            </a:r>
+          </a:p>
+        </p:txBody>
+      </p:sp>
+      <p:sp>
+        <p:nvSpPr>
+          <p:cNvPr id="3" name="מציין מיקום תוכן 2">
+            <a:extLst>
+              <a:ext uri="{FF2B5EF4-FFF2-40B4-BE49-F238E27FC236}">
+                <a16:creationId xmlns:a16="http://schemas.microsoft.com/office/drawing/2014/main" id="{50B7135A-4610-772C-ADD2-011112B4288D}"/>
+              </a:ext>
+            </a:extLst>
+          </p:cNvPr>
+          <p:cNvSpPr>
+            <a:spLocks noGrp="1"/>
+          </p:cNvSpPr>
+          <p:nvPr>
+            <p:ph idx="1"/>
+          </p:nvPr>
+        </p:nvSpPr>
+        <p:spPr/>
+        <p:txBody>
+          <a:bodyPr/>
+          <a:lstStyle/>
+          <a:p>
+            <a:r>
+              <a:rPr lang="he-IL" dirty="0"/>
+              <a:t>שלב 1 – גרעין בסיסי</a:t>
+            </a:r>
+          </a:p>
+          <a:p>
+            <a:pPr lvl="1"/>
+            <a:r>
+              <a:rPr lang="he-IL" dirty="0"/>
+              <a:t>הזנת נקודות ע"י מורה רק סיכום שבועי (פעם בשבוע)</a:t>
+            </a:r>
+          </a:p>
+          <a:p>
+            <a:pPr lvl="1"/>
+            <a:r>
+              <a:rPr lang="he-IL" dirty="0"/>
+              <a:t>תלמידה צופה במצבה השבועי </a:t>
+            </a:r>
+          </a:p>
+          <a:p>
+            <a:pPr lvl="1"/>
+            <a:r>
+              <a:rPr lang="he-IL" dirty="0"/>
+              <a:t>רכישת הזמנה בקיוסק </a:t>
+            </a:r>
+          </a:p>
+        </p:txBody>
+      </p:sp>
+    </p:spTree>
+    <p:extLst>
+      <p:ext uri="{BB962C8B-B14F-4D97-AF65-F5344CB8AC3E}">
+        <p14:creationId xmlns:p14="http://schemas.microsoft.com/office/powerpoint/2010/main" val="3623963840"/>
+      </p:ext>
+    </p:extLst>
+  </p:cSld>
+  <p:clrMapOvr>
+    <a:masterClrMapping/>
+  </p:clrMapOvr>
+</p:sld>
+</file>
+
+<file path=ppt/slides/slide19.xml><?xml version="1.0" encoding="utf-8"?>
+<p:sld xmlns:a="http://schemas.openxmlformats.org/drawingml/2006/main" xmlns:r="http://schemas.openxmlformats.org/officeDocument/2006/relationships" xmlns:p="http://schemas.openxmlformats.org/presentationml/2006/main">
+  <p:cSld>
+    <p:spTree>
+      <p:nvGrpSpPr>
+        <p:cNvPr id="1" name=""/>
+        <p:cNvGrpSpPr/>
+        <p:nvPr/>
+      </p:nvGrpSpPr>
+      <p:grpSpPr>
+        <a:xfrm>
+          <a:off x="0" y="0"/>
+          <a:ext cx="0" cy="0"/>
+          <a:chOff x="0" y="0"/>
+          <a:chExt cx="0" cy="0"/>
+        </a:xfrm>
+      </p:grpSpPr>
+      <p:sp>
+        <p:nvSpPr>
+          <p:cNvPr id="2" name="כותרת 1">
+            <a:extLst>
+              <a:ext uri="{FF2B5EF4-FFF2-40B4-BE49-F238E27FC236}">
+                <a16:creationId xmlns:a16="http://schemas.microsoft.com/office/drawing/2014/main" id="{5A090ED1-DAF7-BEB7-FD34-8E11EBF4BB87}"/>
+              </a:ext>
+            </a:extLst>
+          </p:cNvPr>
+          <p:cNvSpPr>
+            <a:spLocks noGrp="1"/>
+          </p:cNvSpPr>
+          <p:nvPr>
+            <p:ph type="title"/>
+          </p:nvPr>
+        </p:nvSpPr>
+        <p:spPr/>
+        <p:txBody>
+          <a:bodyPr/>
+          <a:lstStyle/>
+          <a:p>
+            <a:r>
+              <a:rPr lang="he-IL" dirty="0"/>
+              <a:t>שלבי פיתוח</a:t>
+            </a:r>
+          </a:p>
+        </p:txBody>
+      </p:sp>
+      <p:sp>
+        <p:nvSpPr>
+          <p:cNvPr id="3" name="מציין מיקום תוכן 2">
+            <a:extLst>
+              <a:ext uri="{FF2B5EF4-FFF2-40B4-BE49-F238E27FC236}">
+                <a16:creationId xmlns:a16="http://schemas.microsoft.com/office/drawing/2014/main" id="{3F66488C-0180-B348-A6A3-48BCBB52AA2C}"/>
+              </a:ext>
+            </a:extLst>
+          </p:cNvPr>
+          <p:cNvSpPr>
+            <a:spLocks noGrp="1"/>
+          </p:cNvSpPr>
+          <p:nvPr>
+            <p:ph idx="1"/>
+          </p:nvPr>
+        </p:nvSpPr>
+        <p:spPr/>
+        <p:txBody>
+          <a:bodyPr/>
+          <a:lstStyle/>
+          <a:p>
+            <a:r>
+              <a:rPr lang="he-IL" dirty="0"/>
+              <a:t>שלב 2 – שיפור חווית משתמש </a:t>
+            </a:r>
+          </a:p>
+          <a:p>
+            <a:pPr lvl="1"/>
+            <a:r>
+              <a:rPr lang="he-IL" dirty="0"/>
+              <a:t>הוספת הודעות מצוות עבור התלמידות</a:t>
+            </a:r>
+          </a:p>
+          <a:p>
+            <a:pPr lvl="1"/>
+            <a:r>
+              <a:rPr lang="he-IL" dirty="0"/>
+              <a:t>הוספת הצעת רעיונות של התלמידות להבאת דברים לקיוסק</a:t>
+            </a:r>
+          </a:p>
+          <a:p>
+            <a:pPr lvl="1"/>
+            <a:r>
+              <a:rPr lang="he-IL" dirty="0"/>
+              <a:t>ניתוח של גרפים חודשיים על בסיס הנתונים השבועיים</a:t>
+            </a:r>
+          </a:p>
+          <a:p>
+            <a:pPr lvl="1"/>
+            <a:endParaRPr lang="he-IL" dirty="0"/>
+          </a:p>
+          <a:p>
+            <a:pPr lvl="1"/>
+            <a:endParaRPr lang="he-IL" dirty="0"/>
+          </a:p>
+        </p:txBody>
+      </p:sp>
+    </p:spTree>
+    <p:extLst>
+      <p:ext uri="{BB962C8B-B14F-4D97-AF65-F5344CB8AC3E}">
+        <p14:creationId xmlns:p14="http://schemas.microsoft.com/office/powerpoint/2010/main" val="1472458659"/>
       </p:ext>
     </p:extLst>
   </p:cSld>
@@ -3570,7 +5126,7 @@
           <p:cNvPr id="2" name="כותרת 1">
             <a:extLst>
               <a:ext uri="{FF2B5EF4-FFF2-40B4-BE49-F238E27FC236}">
-                <a16:creationId xmlns:a16="http://schemas.microsoft.com/office/drawing/2014/main" id="{0D55EC9A-4722-BF0D-D38B-F9D7F2E28C15}"/>
+                <a16:creationId xmlns:a16="http://schemas.microsoft.com/office/drawing/2014/main" id="{F5885D26-079A-786E-F831-D415315F57EE}"/>
               </a:ext>
             </a:extLst>
           </p:cNvPr>
@@ -3587,8 +5143,12 @@
           <a:lstStyle/>
           <a:p>
             <a:r>
-              <a:rPr lang="he-IL" dirty="0"/>
-              <a:t>שלב א</a:t>
+              <a:rPr lang="he-IL" dirty="0" err="1"/>
+              <a:t>חזון</a:t>
+            </a:r>
+            <a:r>
+              <a:rPr lang="he-IL" dirty="0"/>
+              <a:t> ומטרת המערכת</a:t>
             </a:r>
           </a:p>
         </p:txBody>
@@ -3598,7 +5158,7 @@
           <p:cNvPr id="3" name="מציין מיקום תוכן 2">
             <a:extLst>
               <a:ext uri="{FF2B5EF4-FFF2-40B4-BE49-F238E27FC236}">
-                <a16:creationId xmlns:a16="http://schemas.microsoft.com/office/drawing/2014/main" id="{A03D7F0D-2475-7DBD-02FC-6C599794F644}"/>
+                <a16:creationId xmlns:a16="http://schemas.microsoft.com/office/drawing/2014/main" id="{DA16B6B2-EA48-537E-D1CB-78C3360635BD}"/>
               </a:ext>
             </a:extLst>
           </p:cNvPr>
@@ -3611,24 +5171,842 @@
         </p:nvSpPr>
         <p:spPr/>
         <p:txBody>
-          <a:bodyPr/>
-          <a:lstStyle/>
-          <a:p>
-            <a:r>
-              <a:rPr lang="he-IL" dirty="0"/>
-              <a:t>בנית הפרויקט </a:t>
-            </a:r>
-            <a:r>
-              <a:rPr lang="he-IL"/>
-              <a:t>תעשה בשלבים </a:t>
-            </a:r>
+          <a:bodyPr>
+            <a:normAutofit fontScale="85000" lnSpcReduction="20000"/>
+          </a:bodyPr>
+          <a:lstStyle/>
+          <a:p>
+            <a:r>
+              <a:rPr lang="he-IL" dirty="0"/>
+              <a:t>למה המערכת נבנתה?</a:t>
+            </a:r>
+          </a:p>
+          <a:p>
+            <a:pPr marL="457200" lvl="1" indent="0">
+              <a:buNone/>
+            </a:pPr>
+            <a:r>
+              <a:rPr lang="he-IL" dirty="0"/>
+              <a:t>המערכת נבנתה כדי ליצור </a:t>
+            </a:r>
+            <a:r>
+              <a:rPr lang="he-IL" b="1" dirty="0"/>
+              <a:t>מערכת חכמה לניהול, מעקב וחיזוק התנהגות חיובית והצטיינות בקרב תלמידות</a:t>
+            </a:r>
+            <a:r>
+              <a:rPr lang="he-IL" dirty="0"/>
+              <a:t>, תוך חיבור בין צוות חינוכי, תלמידות והנהלה — בצורה מדידה, שקופה ומעודדת מוטיבציה.</a:t>
+            </a:r>
+          </a:p>
+          <a:p>
+            <a:r>
+              <a:rPr lang="he-IL" dirty="0"/>
+              <a:t>איזו בעיה חינוכית וניהולית היא פותרת?</a:t>
+            </a:r>
+          </a:p>
+          <a:p>
+            <a:pPr lvl="1"/>
+            <a:r>
+              <a:rPr lang="he-IL" dirty="0"/>
+              <a:t>לפני המערכת:</a:t>
+            </a:r>
+          </a:p>
+          <a:p>
+            <a:pPr lvl="2"/>
+            <a:r>
+              <a:rPr lang="he-IL" dirty="0"/>
+              <a:t>מעקב אחר נקודות והצטיינות נעשה באופן ידני ולא עקבי</a:t>
+            </a:r>
+          </a:p>
+          <a:p>
+            <a:pPr lvl="2"/>
+            <a:r>
+              <a:rPr lang="he-IL" dirty="0"/>
+              <a:t>לא הייתה תמונה ברורה של התקדמות תלמידות לאורך זמן</a:t>
+            </a:r>
+          </a:p>
+          <a:p>
+            <a:pPr lvl="2"/>
+            <a:r>
+              <a:rPr lang="he-IL" dirty="0"/>
+              <a:t>תלמידות לא קיבלו משוב </a:t>
+            </a:r>
+            <a:r>
+              <a:rPr lang="he-IL" dirty="0" err="1"/>
+              <a:t>מיידי</a:t>
+            </a:r>
+            <a:r>
+              <a:rPr lang="he-IL" dirty="0"/>
+              <a:t> וברור על הישגים</a:t>
+            </a:r>
+          </a:p>
+          <a:p>
+            <a:pPr lvl="2"/>
+            <a:r>
+              <a:rPr lang="he-IL" dirty="0"/>
+              <a:t>ניהול שוברים, תעודות והטבות היה מורכב ולא ממוחשב</a:t>
+            </a:r>
+          </a:p>
+          <a:p>
+            <a:pPr lvl="2"/>
+            <a:r>
+              <a:rPr lang="he-IL" dirty="0"/>
+              <a:t>להנהלה לא הייתה שליטה מלאה על נתונים מצטברים ומגמות</a:t>
+            </a:r>
+          </a:p>
+          <a:p>
+            <a:pPr lvl="1"/>
+            <a:r>
+              <a:rPr lang="he-IL" dirty="0"/>
+              <a:t>המערכת פותרת זאת באמצעות:</a:t>
+            </a:r>
+          </a:p>
+          <a:p>
+            <a:pPr lvl="2"/>
+            <a:r>
+              <a:rPr lang="he-IL" dirty="0"/>
+              <a:t>אוטומציה של חישוב נקודות, הצטיינות ושוברים</a:t>
+            </a:r>
+          </a:p>
+          <a:p>
+            <a:pPr lvl="2"/>
+            <a:r>
+              <a:rPr lang="he-IL" dirty="0"/>
+              <a:t>תיעוד היסטורי מלא של התקדמות אישית וכיתתית</a:t>
+            </a:r>
+          </a:p>
+          <a:p>
+            <a:pPr lvl="2"/>
+            <a:r>
+              <a:rPr lang="he-IL" dirty="0"/>
+              <a:t>מערכת משוב ברורה ושקופה לתלמידות</a:t>
+            </a:r>
+          </a:p>
+          <a:p>
+            <a:pPr lvl="2"/>
+            <a:r>
+              <a:rPr lang="he-IL" dirty="0"/>
+              <a:t>ניהול דיגיטלי של תעודות, שוברים ורכישות</a:t>
+            </a:r>
+          </a:p>
+          <a:p>
+            <a:pPr lvl="2"/>
+            <a:r>
+              <a:rPr lang="he-IL" dirty="0"/>
+              <a:t>ניתוח נתונים מתקדם עבור מורות וצוות ניהולי</a:t>
+            </a:r>
+          </a:p>
+          <a:p>
+            <a:pPr lvl="1"/>
+            <a:endParaRPr lang="he-IL" dirty="0"/>
           </a:p>
         </p:txBody>
       </p:sp>
     </p:spTree>
     <p:extLst>
       <p:ext uri="{BB962C8B-B14F-4D97-AF65-F5344CB8AC3E}">
-        <p14:creationId xmlns:p14="http://schemas.microsoft.com/office/powerpoint/2010/main" val="1320227885"/>
+        <p14:creationId xmlns:p14="http://schemas.microsoft.com/office/powerpoint/2010/main" val="1893569744"/>
+      </p:ext>
+    </p:extLst>
+  </p:cSld>
+  <p:clrMapOvr>
+    <a:masterClrMapping/>
+  </p:clrMapOvr>
+</p:sld>
+</file>
+
+<file path=ppt/slides/slide20.xml><?xml version="1.0" encoding="utf-8"?>
+<p:sld xmlns:a="http://schemas.openxmlformats.org/drawingml/2006/main" xmlns:r="http://schemas.openxmlformats.org/officeDocument/2006/relationships" xmlns:p="http://schemas.openxmlformats.org/presentationml/2006/main">
+  <p:cSld>
+    <p:spTree>
+      <p:nvGrpSpPr>
+        <p:cNvPr id="1" name=""/>
+        <p:cNvGrpSpPr/>
+        <p:nvPr/>
+      </p:nvGrpSpPr>
+      <p:grpSpPr>
+        <a:xfrm>
+          <a:off x="0" y="0"/>
+          <a:ext cx="0" cy="0"/>
+          <a:chOff x="0" y="0"/>
+          <a:chExt cx="0" cy="0"/>
+        </a:xfrm>
+      </p:grpSpPr>
+      <p:sp>
+        <p:nvSpPr>
+          <p:cNvPr id="2" name="כותרת 1">
+            <a:extLst>
+              <a:ext uri="{FF2B5EF4-FFF2-40B4-BE49-F238E27FC236}">
+                <a16:creationId xmlns:a16="http://schemas.microsoft.com/office/drawing/2014/main" id="{D7E85D51-71D9-98A9-2F8D-76B4B093DB71}"/>
+              </a:ext>
+            </a:extLst>
+          </p:cNvPr>
+          <p:cNvSpPr>
+            <a:spLocks noGrp="1"/>
+          </p:cNvSpPr>
+          <p:nvPr>
+            <p:ph type="title"/>
+          </p:nvPr>
+        </p:nvSpPr>
+        <p:spPr/>
+        <p:txBody>
+          <a:bodyPr/>
+          <a:lstStyle/>
+          <a:p>
+            <a:r>
+              <a:rPr lang="he-IL" dirty="0"/>
+              <a:t>שלבי פיתוח </a:t>
+            </a:r>
+          </a:p>
+        </p:txBody>
+      </p:sp>
+      <p:sp>
+        <p:nvSpPr>
+          <p:cNvPr id="3" name="מציין מיקום תוכן 2">
+            <a:extLst>
+              <a:ext uri="{FF2B5EF4-FFF2-40B4-BE49-F238E27FC236}">
+                <a16:creationId xmlns:a16="http://schemas.microsoft.com/office/drawing/2014/main" id="{3E46807F-FBDF-B8AC-7735-A08645771E57}"/>
+              </a:ext>
+            </a:extLst>
+          </p:cNvPr>
+          <p:cNvSpPr>
+            <a:spLocks noGrp="1"/>
+          </p:cNvSpPr>
+          <p:nvPr>
+            <p:ph idx="1"/>
+          </p:nvPr>
+        </p:nvSpPr>
+        <p:spPr/>
+        <p:txBody>
+          <a:bodyPr/>
+          <a:lstStyle/>
+          <a:p>
+            <a:r>
+              <a:rPr lang="he-IL" dirty="0"/>
+              <a:t>שלב 3 – מערכת מתקדמת (היום)</a:t>
+            </a:r>
+          </a:p>
+          <a:p>
+            <a:pPr lvl="1"/>
+            <a:r>
+              <a:rPr lang="he-IL" dirty="0"/>
+              <a:t>הזנת נקודות בכל שיעור </a:t>
+            </a:r>
+          </a:p>
+          <a:p>
+            <a:pPr lvl="1"/>
+            <a:r>
+              <a:rPr lang="he-IL" dirty="0"/>
+              <a:t>חישוב נקודות אוטומטי בסוף כל שבוע</a:t>
+            </a:r>
+          </a:p>
+          <a:p>
+            <a:pPr lvl="1"/>
+            <a:r>
+              <a:rPr lang="he-IL" dirty="0"/>
+              <a:t>קביעה ע"י מורה על הצטיינות שבועית וקבלת שוברים</a:t>
+            </a:r>
+          </a:p>
+          <a:p>
+            <a:pPr lvl="1"/>
+            <a:r>
+              <a:rPr lang="he-IL" dirty="0"/>
+              <a:t>גרפי ניתוח מתקדמים על סמך הנתונים היומיים עבור המורות התלמידות הצוות הטיפולי והניהולי </a:t>
+            </a:r>
+          </a:p>
+          <a:p>
+            <a:pPr lvl="1"/>
+            <a:r>
+              <a:rPr lang="he-IL" dirty="0"/>
+              <a:t>אפשרות לזיהוי מגמות קושי בשיעורים מסוימים על פי זמן השיעור או סוגו – הוספת מערכת שעות לכל כיתה – אופציונלי כרגע בשלב בדיקה</a:t>
+            </a:r>
+          </a:p>
+        </p:txBody>
+      </p:sp>
+    </p:spTree>
+    <p:extLst>
+      <p:ext uri="{BB962C8B-B14F-4D97-AF65-F5344CB8AC3E}">
+        <p14:creationId xmlns:p14="http://schemas.microsoft.com/office/powerpoint/2010/main" val="3334060120"/>
+      </p:ext>
+    </p:extLst>
+  </p:cSld>
+  <p:clrMapOvr>
+    <a:masterClrMapping/>
+  </p:clrMapOvr>
+</p:sld>
+</file>
+
+<file path=ppt/slides/slide21.xml><?xml version="1.0" encoding="utf-8"?>
+<p:sld xmlns:a="http://schemas.openxmlformats.org/drawingml/2006/main" xmlns:r="http://schemas.openxmlformats.org/officeDocument/2006/relationships" xmlns:p="http://schemas.openxmlformats.org/presentationml/2006/main">
+  <p:cSld>
+    <p:spTree>
+      <p:nvGrpSpPr>
+        <p:cNvPr id="1" name=""/>
+        <p:cNvGrpSpPr/>
+        <p:nvPr/>
+      </p:nvGrpSpPr>
+      <p:grpSpPr>
+        <a:xfrm>
+          <a:off x="0" y="0"/>
+          <a:ext cx="0" cy="0"/>
+          <a:chOff x="0" y="0"/>
+          <a:chExt cx="0" cy="0"/>
+        </a:xfrm>
+      </p:grpSpPr>
+      <p:sp>
+        <p:nvSpPr>
+          <p:cNvPr id="2" name="כותרת 1">
+            <a:extLst>
+              <a:ext uri="{FF2B5EF4-FFF2-40B4-BE49-F238E27FC236}">
+                <a16:creationId xmlns:a16="http://schemas.microsoft.com/office/drawing/2014/main" id="{B37ED96D-54A9-1FF5-1767-FECD111F9913}"/>
+              </a:ext>
+            </a:extLst>
+          </p:cNvPr>
+          <p:cNvSpPr>
+            <a:spLocks noGrp="1"/>
+          </p:cNvSpPr>
+          <p:nvPr>
+            <p:ph type="title"/>
+          </p:nvPr>
+        </p:nvSpPr>
+        <p:spPr/>
+        <p:txBody>
+          <a:bodyPr/>
+          <a:lstStyle/>
+          <a:p>
+            <a:r>
+              <a:rPr lang="he-IL" dirty="0"/>
+              <a:t>יכולות עתידיות והתרחבות </a:t>
+            </a:r>
+          </a:p>
+        </p:txBody>
+      </p:sp>
+      <p:sp>
+        <p:nvSpPr>
+          <p:cNvPr id="3" name="מציין מיקום תוכן 2">
+            <a:extLst>
+              <a:ext uri="{FF2B5EF4-FFF2-40B4-BE49-F238E27FC236}">
+                <a16:creationId xmlns:a16="http://schemas.microsoft.com/office/drawing/2014/main" id="{9AC88A1B-3C6C-4BCE-1FB9-16444C87623E}"/>
+              </a:ext>
+            </a:extLst>
+          </p:cNvPr>
+          <p:cNvSpPr>
+            <a:spLocks noGrp="1"/>
+          </p:cNvSpPr>
+          <p:nvPr>
+            <p:ph idx="1"/>
+          </p:nvPr>
+        </p:nvSpPr>
+        <p:spPr/>
+        <p:txBody>
+          <a:bodyPr/>
+          <a:lstStyle/>
+          <a:p>
+            <a:r>
+              <a:rPr lang="he-IL" dirty="0"/>
+              <a:t>המערכת יכולה להתרחב עוד רבות </a:t>
+            </a:r>
+          </a:p>
+          <a:p>
+            <a:pPr lvl="1"/>
+            <a:r>
+              <a:rPr lang="he-IL" dirty="0" err="1"/>
+              <a:t>אוטומציות</a:t>
+            </a:r>
+            <a:r>
+              <a:rPr lang="he-IL" dirty="0"/>
+              <a:t> </a:t>
+            </a:r>
+          </a:p>
+          <a:p>
+            <a:pPr lvl="1"/>
+            <a:r>
+              <a:rPr lang="he-IL" dirty="0"/>
+              <a:t>פיתוחים חינוכיים נוספים</a:t>
+            </a:r>
+          </a:p>
+          <a:p>
+            <a:pPr lvl="1"/>
+            <a:r>
+              <a:rPr lang="he-IL" dirty="0"/>
+              <a:t>הוספת תהליכי </a:t>
+            </a:r>
+            <a:r>
+              <a:rPr lang="en-US" dirty="0"/>
+              <a:t>AI</a:t>
+            </a:r>
+            <a:r>
+              <a:rPr lang="he-IL" dirty="0"/>
+              <a:t> (מה שהוגש למיזם)</a:t>
+            </a:r>
+          </a:p>
+          <a:p>
+            <a:endParaRPr lang="he-IL" dirty="0"/>
+          </a:p>
+        </p:txBody>
+      </p:sp>
+    </p:spTree>
+    <p:extLst>
+      <p:ext uri="{BB962C8B-B14F-4D97-AF65-F5344CB8AC3E}">
+        <p14:creationId xmlns:p14="http://schemas.microsoft.com/office/powerpoint/2010/main" val="2412431786"/>
+      </p:ext>
+    </p:extLst>
+  </p:cSld>
+  <p:clrMapOvr>
+    <a:masterClrMapping/>
+  </p:clrMapOvr>
+</p:sld>
+</file>
+
+<file path=ppt/slides/slide22.xml><?xml version="1.0" encoding="utf-8"?>
+<p:sld xmlns:a="http://schemas.openxmlformats.org/drawingml/2006/main" xmlns:r="http://schemas.openxmlformats.org/officeDocument/2006/relationships" xmlns:p="http://schemas.openxmlformats.org/presentationml/2006/main">
+  <p:cSld>
+    <p:spTree>
+      <p:nvGrpSpPr>
+        <p:cNvPr id="1" name=""/>
+        <p:cNvGrpSpPr/>
+        <p:nvPr/>
+      </p:nvGrpSpPr>
+      <p:grpSpPr>
+        <a:xfrm>
+          <a:off x="0" y="0"/>
+          <a:ext cx="0" cy="0"/>
+          <a:chOff x="0" y="0"/>
+          <a:chExt cx="0" cy="0"/>
+        </a:xfrm>
+      </p:grpSpPr>
+      <p:sp>
+        <p:nvSpPr>
+          <p:cNvPr id="2" name="כותרת 1">
+            <a:extLst>
+              <a:ext uri="{FF2B5EF4-FFF2-40B4-BE49-F238E27FC236}">
+                <a16:creationId xmlns:a16="http://schemas.microsoft.com/office/drawing/2014/main" id="{B5C8EEE7-3484-5EB4-B53C-97589E0F54B9}"/>
+              </a:ext>
+            </a:extLst>
+          </p:cNvPr>
+          <p:cNvSpPr>
+            <a:spLocks noGrp="1"/>
+          </p:cNvSpPr>
+          <p:nvPr>
+            <p:ph type="title"/>
+          </p:nvPr>
+        </p:nvSpPr>
+        <p:spPr/>
+        <p:txBody>
+          <a:bodyPr/>
+          <a:lstStyle/>
+          <a:p>
+            <a:r>
+              <a:rPr lang="he-IL" dirty="0"/>
+              <a:t>סיכום – ערך חינוכי וטכנולוגי</a:t>
+            </a:r>
+          </a:p>
+        </p:txBody>
+      </p:sp>
+      <p:sp>
+        <p:nvSpPr>
+          <p:cNvPr id="3" name="מציין מיקום תוכן 2">
+            <a:extLst>
+              <a:ext uri="{FF2B5EF4-FFF2-40B4-BE49-F238E27FC236}">
+                <a16:creationId xmlns:a16="http://schemas.microsoft.com/office/drawing/2014/main" id="{0BBE8008-94DD-7B70-62AE-F6F7247DB5C0}"/>
+              </a:ext>
+            </a:extLst>
+          </p:cNvPr>
+          <p:cNvSpPr>
+            <a:spLocks noGrp="1"/>
+          </p:cNvSpPr>
+          <p:nvPr>
+            <p:ph idx="1"/>
+          </p:nvPr>
+        </p:nvSpPr>
+        <p:spPr/>
+        <p:txBody>
+          <a:bodyPr>
+            <a:normAutofit fontScale="70000" lnSpcReduction="20000"/>
+          </a:bodyPr>
+          <a:lstStyle/>
+          <a:p>
+            <a:r>
+              <a:rPr lang="he-IL" dirty="0"/>
+              <a:t>תרומה לבית הספר</a:t>
+            </a:r>
+          </a:p>
+          <a:p>
+            <a:pPr lvl="1"/>
+            <a:r>
+              <a:rPr lang="he-IL" dirty="0"/>
+              <a:t>המערכת מעניקה לבית הספר </a:t>
+            </a:r>
+            <a:r>
+              <a:rPr lang="he-IL" b="1" dirty="0"/>
+              <a:t>כלי ניהולי וחינוכי מתקדם</a:t>
+            </a:r>
+            <a:r>
+              <a:rPr lang="he-IL" dirty="0"/>
+              <a:t> לניהול נתוני התנהגות, הצטיינות ומעורבות תלמידות.</a:t>
+            </a:r>
+            <a:br>
+              <a:rPr lang="he-IL" dirty="0"/>
+            </a:br>
+            <a:r>
+              <a:rPr lang="he-IL" dirty="0"/>
+              <a:t>היא מאפשרת </a:t>
+            </a:r>
+            <a:r>
+              <a:rPr lang="he-IL" b="1" dirty="0"/>
+              <a:t>בקרה, שקיפות וקבלת החלטות מבוססת נתונים</a:t>
+            </a:r>
+            <a:r>
+              <a:rPr lang="he-IL" dirty="0"/>
+              <a:t>, מפחיתה עומס אדמיניסטרטיבי ומחזקת תרבות של מצוינות, אחריות והתמדה.</a:t>
+            </a:r>
+          </a:p>
+          <a:p>
+            <a:r>
+              <a:rPr lang="he-IL" dirty="0"/>
+              <a:t>תרומה לתלמידות</a:t>
+            </a:r>
+          </a:p>
+          <a:p>
+            <a:pPr lvl="1"/>
+            <a:r>
+              <a:rPr lang="he-IL" dirty="0"/>
+              <a:t>המערכת יוצרת </a:t>
+            </a:r>
+            <a:r>
+              <a:rPr lang="he-IL" b="1" dirty="0"/>
+              <a:t>חוויית למידה מעצימה ומעודדת</a:t>
+            </a:r>
+            <a:r>
+              <a:rPr lang="he-IL" dirty="0"/>
+              <a:t>, המבוססת על משוב חיובי, הכרה בהישגים ומוטיבציה פנימית.</a:t>
+            </a:r>
+            <a:br>
+              <a:rPr lang="he-IL" dirty="0"/>
+            </a:br>
+            <a:r>
+              <a:rPr lang="he-IL" dirty="0"/>
+              <a:t>התלמידות מקבלות </a:t>
+            </a:r>
+            <a:r>
+              <a:rPr lang="he-IL" b="1" dirty="0"/>
+              <a:t>תמונה ברורה של ההתקדמות האישית שלהן</a:t>
+            </a:r>
+            <a:r>
+              <a:rPr lang="he-IL" dirty="0"/>
+              <a:t>, תחושת מסוגלות, מפת דרך להצלחה וחיבור ישיר בין מאמץ - להישג.</a:t>
+            </a:r>
+          </a:p>
+          <a:p>
+            <a:r>
+              <a:rPr lang="he-IL" dirty="0"/>
+              <a:t>פוטנציאל עתידי</a:t>
+            </a:r>
+          </a:p>
+          <a:p>
+            <a:pPr lvl="1"/>
+            <a:r>
+              <a:rPr lang="he-IL" dirty="0"/>
+              <a:t>המערכת נבנתה עם </a:t>
+            </a:r>
+            <a:r>
+              <a:rPr lang="he-IL" b="1" dirty="0"/>
+              <a:t>תשתית גמישה להתרחבות עתידית</a:t>
+            </a:r>
+            <a:r>
+              <a:rPr lang="he-IL" dirty="0"/>
+              <a:t>, ויכולה לשמש בסיס לפיתוחים נוספים, כגון:</a:t>
+            </a:r>
+          </a:p>
+          <a:p>
+            <a:pPr lvl="1"/>
+            <a:r>
+              <a:rPr lang="he-IL" dirty="0"/>
+              <a:t>הרחבת אזור הניהול והדוחות המתקדמים</a:t>
+            </a:r>
+          </a:p>
+          <a:p>
+            <a:pPr lvl="1"/>
+            <a:r>
+              <a:rPr lang="he-IL" dirty="0"/>
+              <a:t>ניתוח חינוכי חכם לזיהוי דפוסי הצלחה ואתגר</a:t>
+            </a:r>
+          </a:p>
+          <a:p>
+            <a:pPr lvl="1"/>
+            <a:r>
+              <a:rPr lang="he-IL" dirty="0" err="1"/>
+              <a:t>אוטומציות</a:t>
+            </a:r>
+            <a:r>
+              <a:rPr lang="he-IL" dirty="0"/>
+              <a:t> לתהליכים חינוכיים וניהוליים</a:t>
+            </a:r>
+          </a:p>
+          <a:p>
+            <a:pPr lvl="1"/>
+            <a:r>
+              <a:rPr lang="he-IL" dirty="0"/>
+              <a:t>התאמה למוסדות חינוך נוספים </a:t>
+            </a:r>
+            <a:r>
+              <a:rPr lang="he-IL" dirty="0" err="1"/>
+              <a:t>וסקייל</a:t>
+            </a:r>
+            <a:r>
+              <a:rPr lang="he-IL" dirty="0"/>
+              <a:t> עתידי</a:t>
+            </a:r>
+          </a:p>
+          <a:p>
+            <a:r>
+              <a:rPr lang="he-IL" dirty="0"/>
+              <a:t>לא רק מערכת טכנולוגית - אלא מנוע לצמיחה חינוכית.</a:t>
+            </a:r>
+          </a:p>
+        </p:txBody>
+      </p:sp>
+    </p:spTree>
+    <p:extLst>
+      <p:ext uri="{BB962C8B-B14F-4D97-AF65-F5344CB8AC3E}">
+        <p14:creationId xmlns:p14="http://schemas.microsoft.com/office/powerpoint/2010/main" val="2938246688"/>
+      </p:ext>
+    </p:extLst>
+  </p:cSld>
+  <p:clrMapOvr>
+    <a:masterClrMapping/>
+  </p:clrMapOvr>
+</p:sld>
+</file>
+
+<file path=ppt/slides/slide23.xml><?xml version="1.0" encoding="utf-8"?>
+<p:sld xmlns:a="http://schemas.openxmlformats.org/drawingml/2006/main" xmlns:r="http://schemas.openxmlformats.org/officeDocument/2006/relationships" xmlns:p="http://schemas.openxmlformats.org/presentationml/2006/main">
+  <p:cSld>
+    <p:spTree>
+      <p:nvGrpSpPr>
+        <p:cNvPr id="1" name=""/>
+        <p:cNvGrpSpPr/>
+        <p:nvPr/>
+      </p:nvGrpSpPr>
+      <p:grpSpPr>
+        <a:xfrm>
+          <a:off x="0" y="0"/>
+          <a:ext cx="0" cy="0"/>
+          <a:chOff x="0" y="0"/>
+          <a:chExt cx="0" cy="0"/>
+        </a:xfrm>
+      </p:grpSpPr>
+      <p:pic>
+        <p:nvPicPr>
+          <p:cNvPr id="4" name="תמונה 3">
+            <a:extLst>
+              <a:ext uri="{FF2B5EF4-FFF2-40B4-BE49-F238E27FC236}">
+                <a16:creationId xmlns:a16="http://schemas.microsoft.com/office/drawing/2014/main" id="{4F9EF8B7-6A9F-B447-B80C-15D9F1A2BB58}"/>
+              </a:ext>
+            </a:extLst>
+          </p:cNvPr>
+          <p:cNvPicPr>
+            <a:picLocks noChangeAspect="1"/>
+          </p:cNvPicPr>
+          <p:nvPr/>
+        </p:nvPicPr>
+        <p:blipFill>
+          <a:blip r:embed="rId2">
+            <a:extLst>
+              <a:ext uri="{28A0092B-C50C-407E-A947-70E740481C1C}">
+                <a14:useLocalDpi xmlns:a14="http://schemas.microsoft.com/office/drawing/2010/main" val="0"/>
+              </a:ext>
+            </a:extLst>
+          </a:blip>
+          <a:stretch>
+            <a:fillRect/>
+          </a:stretch>
+        </p:blipFill>
+        <p:spPr>
+          <a:xfrm>
+            <a:off x="0" y="-873558"/>
+            <a:ext cx="3656804" cy="3899767"/>
+          </a:xfrm>
+          <a:prstGeom prst="rect">
+            <a:avLst/>
+          </a:prstGeom>
+        </p:spPr>
+      </p:pic>
+      <p:sp>
+        <p:nvSpPr>
+          <p:cNvPr id="7" name="כותרת 1">
+            <a:extLst>
+              <a:ext uri="{FF2B5EF4-FFF2-40B4-BE49-F238E27FC236}">
+                <a16:creationId xmlns:a16="http://schemas.microsoft.com/office/drawing/2014/main" id="{2DE4E65B-E66F-980F-68B8-B3EF13164A74}"/>
+              </a:ext>
+            </a:extLst>
+          </p:cNvPr>
+          <p:cNvSpPr txBox="1">
+            <a:spLocks/>
+          </p:cNvSpPr>
+          <p:nvPr/>
+        </p:nvSpPr>
+        <p:spPr>
+          <a:xfrm>
+            <a:off x="838200" y="2429595"/>
+            <a:ext cx="10515600" cy="1325563"/>
+          </a:xfrm>
+          <a:prstGeom prst="rect">
+            <a:avLst/>
+          </a:prstGeom>
+        </p:spPr>
+        <p:txBody>
+          <a:bodyPr vert="horz" lIns="91440" tIns="45720" rIns="91440" bIns="45720" rtlCol="1" anchor="ctr">
+            <a:normAutofit/>
+          </a:bodyPr>
+          <a:lstStyle>
+            <a:lvl1pPr algn="r" defTabSz="914400" rtl="1" eaLnBrk="1" latinLnBrk="0" hangingPunct="1">
+              <a:lnSpc>
+                <a:spcPct val="90000"/>
+              </a:lnSpc>
+              <a:spcBef>
+                <a:spcPct val="0"/>
+              </a:spcBef>
+              <a:buNone/>
+              <a:defRPr sz="4400" kern="1200">
+                <a:solidFill>
+                  <a:schemeClr val="tx1"/>
+                </a:solidFill>
+                <a:latin typeface="+mj-lt"/>
+                <a:ea typeface="+mj-ea"/>
+                <a:cs typeface="+mj-cs"/>
+              </a:defRPr>
+            </a:lvl1pPr>
+          </a:lstStyle>
+          <a:p>
+            <a:pPr algn="ctr"/>
+            <a:r>
+              <a:rPr lang="en-US" sz="7200" b="1"/>
+              <a:t>Thank you! </a:t>
+            </a:r>
+            <a:endParaRPr lang="he-IL" sz="7200" b="1" dirty="0"/>
+          </a:p>
+        </p:txBody>
+      </p:sp>
+      <p:sp>
+        <p:nvSpPr>
+          <p:cNvPr id="8" name="מלבן 7">
+            <a:extLst>
+              <a:ext uri="{FF2B5EF4-FFF2-40B4-BE49-F238E27FC236}">
+                <a16:creationId xmlns:a16="http://schemas.microsoft.com/office/drawing/2014/main" id="{A56E48FE-7820-D19B-A634-DCCBAB70C97D}"/>
+              </a:ext>
+            </a:extLst>
+          </p:cNvPr>
+          <p:cNvSpPr/>
+          <p:nvPr/>
+        </p:nvSpPr>
+        <p:spPr>
+          <a:xfrm>
+            <a:off x="7393646" y="4475623"/>
+            <a:ext cx="3946914" cy="1969770"/>
+          </a:xfrm>
+          <a:prstGeom prst="rect">
+            <a:avLst/>
+          </a:prstGeom>
+          <a:noFill/>
+        </p:spPr>
+        <p:txBody>
+          <a:bodyPr wrap="none" lIns="91440" tIns="45720" rIns="91440" bIns="45720">
+            <a:spAutoFit/>
+          </a:bodyPr>
+          <a:lstStyle/>
+          <a:p>
+            <a:pPr algn="ctr"/>
+            <a:r>
+              <a:rPr lang="en-US" sz="5400" b="1" cap="none" spc="0" dirty="0">
+                <a:ln w="0"/>
+                <a:solidFill>
+                  <a:schemeClr val="tx1"/>
+                </a:solidFill>
+                <a:effectLst>
+                  <a:outerShdw blurRad="38100" dist="19050" dir="2700000" algn="tl" rotWithShape="0">
+                    <a:schemeClr val="dk1">
+                      <a:alpha val="40000"/>
+                    </a:schemeClr>
+                  </a:outerShdw>
+                </a:effectLst>
+                <a:latin typeface="Bradley Hand ITC" panose="03070402050302030203" pitchFamily="66" charset="0"/>
+                <a:cs typeface="Guttman Yad-Brush" panose="02010401010101010101" pitchFamily="2" charset="-79"/>
+              </a:rPr>
+              <a:t>Sara Hartuv</a:t>
+            </a:r>
+          </a:p>
+          <a:p>
+            <a:pPr algn="ctr"/>
+            <a:r>
+              <a:rPr lang="en-US" sz="2400" dirty="0">
+                <a:ln w="0"/>
+                <a:effectLst>
+                  <a:outerShdw blurRad="38100" dist="19050" dir="2700000" algn="tl" rotWithShape="0">
+                    <a:schemeClr val="dk1">
+                      <a:alpha val="40000"/>
+                    </a:schemeClr>
+                  </a:outerShdw>
+                </a:effectLst>
+                <a:latin typeface="Bradley Hand ITC" panose="03070402050302030203" pitchFamily="66" charset="0"/>
+              </a:rPr>
+              <a:t>sarahartuv1@gmail.com</a:t>
+            </a:r>
+            <a:r>
+              <a:rPr lang="en-US" sz="2400" b="1" cap="none" spc="0" dirty="0">
+                <a:ln w="0"/>
+                <a:solidFill>
+                  <a:schemeClr val="tx1"/>
+                </a:solidFill>
+                <a:effectLst>
+                  <a:outerShdw blurRad="38100" dist="19050" dir="2700000" algn="tl" rotWithShape="0">
+                    <a:schemeClr val="dk1">
+                      <a:alpha val="40000"/>
+                    </a:schemeClr>
+                  </a:outerShdw>
+                </a:effectLst>
+                <a:latin typeface="Bradley Hand ITC" panose="03070402050302030203" pitchFamily="66" charset="0"/>
+                <a:cs typeface="Guttman Yad-Brush" panose="02010401010101010101" pitchFamily="2" charset="-79"/>
+              </a:rPr>
+              <a:t> </a:t>
+            </a:r>
+          </a:p>
+          <a:p>
+            <a:pPr algn="ctr"/>
+            <a:r>
+              <a:rPr lang="en-US" sz="4000" dirty="0">
+                <a:ln w="0"/>
+                <a:effectLst>
+                  <a:outerShdw blurRad="38100" dist="19050" dir="2700000" algn="tl" rotWithShape="0">
+                    <a:schemeClr val="dk1">
+                      <a:alpha val="40000"/>
+                    </a:schemeClr>
+                  </a:outerShdw>
+                </a:effectLst>
+                <a:latin typeface="Bradley Hand ITC" panose="03070402050302030203" pitchFamily="66" charset="0"/>
+                <a:cs typeface="Guttman Yad-Brush" panose="02010401010101010101" pitchFamily="2" charset="-79"/>
+              </a:rPr>
+              <a:t>22/01/2026</a:t>
+            </a:r>
+            <a:endParaRPr lang="he-IL" sz="4000" dirty="0">
+              <a:ln w="0"/>
+              <a:effectLst>
+                <a:outerShdw blurRad="38100" dist="19050" dir="2700000" algn="tl" rotWithShape="0">
+                  <a:schemeClr val="dk1">
+                    <a:alpha val="40000"/>
+                  </a:schemeClr>
+                </a:outerShdw>
+              </a:effectLst>
+              <a:latin typeface="Bradley Hand ITC" panose="03070402050302030203" pitchFamily="66" charset="0"/>
+              <a:cs typeface="Guttman Yad-Brush" panose="02010401010101010101" pitchFamily="2" charset="-79"/>
+            </a:endParaRPr>
+          </a:p>
+        </p:txBody>
+      </p:sp>
+    </p:spTree>
+    <p:extLst>
+      <p:ext uri="{BB962C8B-B14F-4D97-AF65-F5344CB8AC3E}">
+        <p14:creationId xmlns:p14="http://schemas.microsoft.com/office/powerpoint/2010/main" val="1204733904"/>
       </p:ext>
     </p:extLst>
   </p:cSld>
@@ -3660,7 +6038,7 @@
           <p:cNvPr id="2" name="כותרת 1">
             <a:extLst>
               <a:ext uri="{FF2B5EF4-FFF2-40B4-BE49-F238E27FC236}">
-                <a16:creationId xmlns:a16="http://schemas.microsoft.com/office/drawing/2014/main" id="{40096C02-3D4F-6469-12FE-E7DE29CFFC2D}"/>
+                <a16:creationId xmlns:a16="http://schemas.microsoft.com/office/drawing/2014/main" id="{E31B075C-FA28-9043-EACD-1423641CC532}"/>
               </a:ext>
             </a:extLst>
           </p:cNvPr>
@@ -3677,8 +6055,12 @@
           <a:lstStyle/>
           <a:p>
             <a:r>
-              <a:rPr lang="he-IL" dirty="0"/>
-              <a:t>תהליך הכנסת ניקוד לתלמידה </a:t>
+              <a:rPr lang="he-IL" dirty="0" err="1"/>
+              <a:t>חזון</a:t>
+            </a:r>
+            <a:r>
+              <a:rPr lang="he-IL" dirty="0"/>
+              <a:t> ומטרת המערכת - המשך</a:t>
             </a:r>
           </a:p>
         </p:txBody>
@@ -3688,7 +6070,7 @@
           <p:cNvPr id="3" name="מציין מיקום תוכן 2">
             <a:extLst>
               <a:ext uri="{FF2B5EF4-FFF2-40B4-BE49-F238E27FC236}">
-                <a16:creationId xmlns:a16="http://schemas.microsoft.com/office/drawing/2014/main" id="{911406EF-49D3-C525-FC8F-CA633CEE7EBA}"/>
+                <a16:creationId xmlns:a16="http://schemas.microsoft.com/office/drawing/2014/main" id="{589C7F9D-44A1-3113-33AD-583134914215}"/>
               </a:ext>
             </a:extLst>
           </p:cNvPr>
@@ -3701,59 +6083,747 @@
         </p:nvSpPr>
         <p:spPr/>
         <p:txBody>
-          <a:bodyPr/>
-          <a:lstStyle/>
-          <a:p>
-            <a:r>
-              <a:rPr lang="he-IL" dirty="0"/>
-              <a:t>לכל כיתה מספר סף של נקודות לצורך קבלת שובר ?</a:t>
+          <a:bodyPr>
+            <a:normAutofit/>
+          </a:bodyPr>
+          <a:lstStyle/>
+          <a:p>
+            <a:r>
+              <a:rPr lang="he-IL" dirty="0"/>
+              <a:t>הערך המוסף לבית הספר ולתלמידות</a:t>
             </a:r>
           </a:p>
           <a:p>
             <a:pPr lvl="1"/>
             <a:r>
               <a:rPr lang="he-IL" dirty="0"/>
-              <a:t>הצעה ל </a:t>
-            </a:r>
-            <a:r>
-              <a:rPr lang="en-US" dirty="0"/>
-              <a:t>UI</a:t>
-            </a:r>
-            <a:r>
-              <a:rPr lang="he-IL" dirty="0"/>
-              <a:t> לכל כיתה לפי הסף שלה יופיע למורה בצבע מודגש התלמידות הזכאיות לשובר והמורה תחליט מי מקבלת שובר השבוע </a:t>
+              <a:t>לבית הספר:</a:t>
+            </a:r>
+          </a:p>
+          <a:p>
+            <a:pPr lvl="2"/>
+            <a:r>
+              <a:rPr lang="he-IL" dirty="0"/>
+              <a:t>שליטה מלאה על נתונים חינוכיים בזמן אמת</a:t>
+            </a:r>
+          </a:p>
+          <a:p>
+            <a:pPr lvl="2"/>
+            <a:r>
+              <a:rPr lang="he-IL" dirty="0"/>
+              <a:t>קבלת החלטות מבוססת נתונים</a:t>
+            </a:r>
+          </a:p>
+          <a:p>
+            <a:pPr lvl="2"/>
+            <a:r>
+              <a:rPr lang="he-IL" dirty="0"/>
+              <a:t>חיזוק תרבות של מצוינות, התמדה ואחריות</a:t>
+            </a:r>
+          </a:p>
+          <a:p>
+            <a:pPr lvl="2"/>
+            <a:r>
+              <a:rPr lang="he-IL" dirty="0"/>
+              <a:t>חיסכון בזמן ניהולי והפחתת עומס אדמיניסטרטיבי</a:t>
             </a:r>
           </a:p>
           <a:p>
             <a:pPr lvl="1"/>
-            <a:endParaRPr lang="he-IL" dirty="0"/>
-          </a:p>
-          <a:p>
-            <a:r>
-              <a:rPr lang="he-IL" dirty="0"/>
-              <a:t> בכל שבוע המערכת מתאפסת והמורה צריכה להכניס מחדש את נתוני השבוע הזה </a:t>
-            </a:r>
-          </a:p>
-          <a:p>
-            <a:pPr lvl="1"/>
-            <a:r>
-              <a:rPr lang="he-IL"/>
-              <a:t>המורה תוכל להיכנס להיסטוריה ולראות את נתוני השבוע הקודם החודש הקודם היסטוריה של כל השנה וכו'</a:t>
-            </a:r>
-          </a:p>
-          <a:p>
-            <a:endParaRPr lang="he-IL" dirty="0"/>
-          </a:p>
-          <a:p>
-            <a:pPr lvl="1"/>
-            <a:endParaRPr lang="he-IL" dirty="0"/>
+            <a:r>
+              <a:rPr lang="he-IL" dirty="0"/>
+              <a:t>לתלמידות:</a:t>
+            </a:r>
+          </a:p>
+          <a:p>
+            <a:pPr lvl="2"/>
+            <a:r>
+              <a:rPr lang="he-IL" dirty="0"/>
+              <a:t>חוויית למידה מעצימה ומעודדת מוטיבציה</a:t>
+            </a:r>
+          </a:p>
+          <a:p>
+            <a:pPr lvl="2"/>
+            <a:r>
+              <a:rPr lang="he-IL" dirty="0"/>
+              <a:t>שקיפות מלאה לגבי הישגים והתקדמות</a:t>
+            </a:r>
+          </a:p>
+          <a:p>
+            <a:pPr lvl="2"/>
+            <a:r>
+              <a:rPr lang="he-IL" dirty="0"/>
+              <a:t>תחושת הישג, הכרה </a:t>
+            </a:r>
+            <a:r>
+              <a:rPr lang="he-IL" dirty="0" err="1"/>
+              <a:t>ותמרוץ</a:t>
+            </a:r>
+            <a:r>
+              <a:rPr lang="he-IL" dirty="0"/>
+              <a:t> חיובי</a:t>
+            </a:r>
+          </a:p>
+          <a:p>
+            <a:pPr lvl="2"/>
+            <a:r>
+              <a:rPr lang="he-IL" dirty="0"/>
+              <a:t>מפת דרך ברורה להצטיינות אישית וחודשית</a:t>
+            </a:r>
           </a:p>
         </p:txBody>
       </p:sp>
     </p:spTree>
     <p:extLst>
       <p:ext uri="{BB962C8B-B14F-4D97-AF65-F5344CB8AC3E}">
-        <p14:creationId xmlns:p14="http://schemas.microsoft.com/office/powerpoint/2010/main" val="870806376"/>
+        <p14:creationId xmlns:p14="http://schemas.microsoft.com/office/powerpoint/2010/main" val="3003923447"/>
+      </p:ext>
+    </p:extLst>
+  </p:cSld>
+  <p:clrMapOvr>
+    <a:masterClrMapping/>
+  </p:clrMapOvr>
+</p:sld>
+</file>
+
+<file path=ppt/slides/slide4.xml><?xml version="1.0" encoding="utf-8"?>
+<p:sld xmlns:a="http://schemas.openxmlformats.org/drawingml/2006/main" xmlns:r="http://schemas.openxmlformats.org/officeDocument/2006/relationships" xmlns:p="http://schemas.openxmlformats.org/presentationml/2006/main">
+  <p:cSld>
+    <p:spTree>
+      <p:nvGrpSpPr>
+        <p:cNvPr id="1" name=""/>
+        <p:cNvGrpSpPr/>
+        <p:nvPr/>
+      </p:nvGrpSpPr>
+      <p:grpSpPr>
+        <a:xfrm>
+          <a:off x="0" y="0"/>
+          <a:ext cx="0" cy="0"/>
+          <a:chOff x="0" y="0"/>
+          <a:chExt cx="0" cy="0"/>
+        </a:xfrm>
+      </p:grpSpPr>
+      <p:sp>
+        <p:nvSpPr>
+          <p:cNvPr id="2" name="כותרת 1">
+            <a:extLst>
+              <a:ext uri="{FF2B5EF4-FFF2-40B4-BE49-F238E27FC236}">
+                <a16:creationId xmlns:a16="http://schemas.microsoft.com/office/drawing/2014/main" id="{EA6AC487-3DA4-F3DF-BAD4-5D23AE5180D2}"/>
+              </a:ext>
+            </a:extLst>
+          </p:cNvPr>
+          <p:cNvSpPr>
+            <a:spLocks noGrp="1"/>
+          </p:cNvSpPr>
+          <p:nvPr>
+            <p:ph type="title"/>
+          </p:nvPr>
+        </p:nvSpPr>
+        <p:spPr/>
+        <p:txBody>
+          <a:bodyPr/>
+          <a:lstStyle/>
+          <a:p>
+            <a:r>
+              <a:rPr lang="he-IL" dirty="0"/>
+              <a:t>קהל יעד וסוגי משתמשים</a:t>
+            </a:r>
+          </a:p>
+        </p:txBody>
+      </p:sp>
+      <p:sp>
+        <p:nvSpPr>
+          <p:cNvPr id="3" name="מציין מיקום תוכן 2">
+            <a:extLst>
+              <a:ext uri="{FF2B5EF4-FFF2-40B4-BE49-F238E27FC236}">
+                <a16:creationId xmlns:a16="http://schemas.microsoft.com/office/drawing/2014/main" id="{62107DB8-07A9-8BDB-565F-112580970CA7}"/>
+              </a:ext>
+            </a:extLst>
+          </p:cNvPr>
+          <p:cNvSpPr>
+            <a:spLocks noGrp="1"/>
+          </p:cNvSpPr>
+          <p:nvPr>
+            <p:ph idx="1"/>
+          </p:nvPr>
+        </p:nvSpPr>
+        <p:spPr/>
+        <p:txBody>
+          <a:bodyPr/>
+          <a:lstStyle/>
+          <a:p>
+            <a:r>
+              <a:rPr lang="he-IL" dirty="0"/>
+              <a:t>מורות</a:t>
+            </a:r>
+          </a:p>
+          <a:p>
+            <a:r>
+              <a:rPr lang="he-IL" dirty="0"/>
+              <a:t>תלמידות</a:t>
+            </a:r>
+          </a:p>
+          <a:p>
+            <a:r>
+              <a:rPr lang="he-IL" dirty="0"/>
+              <a:t>צוות ניהולי וטיפולי</a:t>
+            </a:r>
+          </a:p>
+          <a:p>
+            <a:r>
+              <a:rPr lang="he-IL" dirty="0"/>
+              <a:t>מנהלת אתר</a:t>
+            </a:r>
+          </a:p>
+        </p:txBody>
+      </p:sp>
+    </p:spTree>
+    <p:extLst>
+      <p:ext uri="{BB962C8B-B14F-4D97-AF65-F5344CB8AC3E}">
+        <p14:creationId xmlns:p14="http://schemas.microsoft.com/office/powerpoint/2010/main" val="1831852507"/>
+      </p:ext>
+    </p:extLst>
+  </p:cSld>
+  <p:clrMapOvr>
+    <a:masterClrMapping/>
+  </p:clrMapOvr>
+</p:sld>
+</file>
+
+<file path=ppt/slides/slide5.xml><?xml version="1.0" encoding="utf-8"?>
+<p:sld xmlns:a="http://schemas.openxmlformats.org/drawingml/2006/main" xmlns:r="http://schemas.openxmlformats.org/officeDocument/2006/relationships" xmlns:p="http://schemas.openxmlformats.org/presentationml/2006/main">
+  <p:cSld>
+    <p:spTree>
+      <p:nvGrpSpPr>
+        <p:cNvPr id="1" name=""/>
+        <p:cNvGrpSpPr/>
+        <p:nvPr/>
+      </p:nvGrpSpPr>
+      <p:grpSpPr>
+        <a:xfrm>
+          <a:off x="0" y="0"/>
+          <a:ext cx="0" cy="0"/>
+          <a:chOff x="0" y="0"/>
+          <a:chExt cx="0" cy="0"/>
+        </a:xfrm>
+      </p:grpSpPr>
+      <p:sp>
+        <p:nvSpPr>
+          <p:cNvPr id="2" name="כותרת 1">
+            <a:extLst>
+              <a:ext uri="{FF2B5EF4-FFF2-40B4-BE49-F238E27FC236}">
+                <a16:creationId xmlns:a16="http://schemas.microsoft.com/office/drawing/2014/main" id="{2814CDED-1672-FCBB-8647-7D179F3CBDBD}"/>
+              </a:ext>
+            </a:extLst>
+          </p:cNvPr>
+          <p:cNvSpPr>
+            <a:spLocks noGrp="1"/>
+          </p:cNvSpPr>
+          <p:nvPr>
+            <p:ph type="title"/>
+          </p:nvPr>
+        </p:nvSpPr>
+        <p:spPr/>
+        <p:txBody>
+          <a:bodyPr/>
+          <a:lstStyle/>
+          <a:p>
+            <a:r>
+              <a:rPr lang="he-IL" dirty="0"/>
+              <a:t>עקרונות מערכתיים מרכזיים</a:t>
+            </a:r>
+          </a:p>
+        </p:txBody>
+      </p:sp>
+      <p:sp>
+        <p:nvSpPr>
+          <p:cNvPr id="3" name="מציין מיקום תוכן 2">
+            <a:extLst>
+              <a:ext uri="{FF2B5EF4-FFF2-40B4-BE49-F238E27FC236}">
+                <a16:creationId xmlns:a16="http://schemas.microsoft.com/office/drawing/2014/main" id="{73BF3EA9-AC18-F52B-AADA-4EC0A124FECC}"/>
+              </a:ext>
+            </a:extLst>
+          </p:cNvPr>
+          <p:cNvSpPr>
+            <a:spLocks noGrp="1"/>
+          </p:cNvSpPr>
+          <p:nvPr>
+            <p:ph idx="1"/>
+          </p:nvPr>
+        </p:nvSpPr>
+        <p:spPr/>
+        <p:txBody>
+          <a:bodyPr/>
+          <a:lstStyle/>
+          <a:p>
+            <a:r>
+              <a:rPr lang="he-IL" dirty="0"/>
+              <a:t>צבירת נקודות</a:t>
+            </a:r>
+          </a:p>
+          <a:p>
+            <a:r>
+              <a:rPr lang="he-IL" dirty="0"/>
+              <a:t>הצטיינות שבועית</a:t>
+            </a:r>
+          </a:p>
+          <a:p>
+            <a:r>
+              <a:rPr lang="he-IL" dirty="0"/>
+              <a:t>שוברים ותעודות </a:t>
+            </a:r>
+            <a:r>
+              <a:rPr lang="he-IL" dirty="0" err="1"/>
+              <a:t>שבועויות</a:t>
+            </a:r>
+            <a:endParaRPr lang="he-IL" dirty="0"/>
+          </a:p>
+          <a:p>
+            <a:r>
+              <a:rPr lang="he-IL" dirty="0"/>
+              <a:t>מעקב היסטוריה וגרפים</a:t>
+            </a:r>
+          </a:p>
+          <a:p>
+            <a:r>
+              <a:rPr lang="he-IL" dirty="0"/>
+              <a:t>קיוסק ומימוש שוברים</a:t>
+            </a:r>
+          </a:p>
+        </p:txBody>
+      </p:sp>
+    </p:spTree>
+    <p:extLst>
+      <p:ext uri="{BB962C8B-B14F-4D97-AF65-F5344CB8AC3E}">
+        <p14:creationId xmlns:p14="http://schemas.microsoft.com/office/powerpoint/2010/main" val="2692338858"/>
+      </p:ext>
+    </p:extLst>
+  </p:cSld>
+  <p:clrMapOvr>
+    <a:masterClrMapping/>
+  </p:clrMapOvr>
+</p:sld>
+</file>
+
+<file path=ppt/slides/slide6.xml><?xml version="1.0" encoding="utf-8"?>
+<p:sld xmlns:a="http://schemas.openxmlformats.org/drawingml/2006/main" xmlns:r="http://schemas.openxmlformats.org/officeDocument/2006/relationships" xmlns:p="http://schemas.openxmlformats.org/presentationml/2006/main">
+  <p:cSld>
+    <p:spTree>
+      <p:nvGrpSpPr>
+        <p:cNvPr id="1" name=""/>
+        <p:cNvGrpSpPr/>
+        <p:nvPr/>
+      </p:nvGrpSpPr>
+      <p:grpSpPr>
+        <a:xfrm>
+          <a:off x="0" y="0"/>
+          <a:ext cx="0" cy="0"/>
+          <a:chOff x="0" y="0"/>
+          <a:chExt cx="0" cy="0"/>
+        </a:xfrm>
+      </p:grpSpPr>
+      <p:sp>
+        <p:nvSpPr>
+          <p:cNvPr id="2" name="כותרת 1">
+            <a:extLst>
+              <a:ext uri="{FF2B5EF4-FFF2-40B4-BE49-F238E27FC236}">
+                <a16:creationId xmlns:a16="http://schemas.microsoft.com/office/drawing/2014/main" id="{BCE83553-1686-399A-AAB4-CB0C3BD810B9}"/>
+              </a:ext>
+            </a:extLst>
+          </p:cNvPr>
+          <p:cNvSpPr>
+            <a:spLocks noGrp="1"/>
+          </p:cNvSpPr>
+          <p:nvPr>
+            <p:ph type="title"/>
+          </p:nvPr>
+        </p:nvSpPr>
+        <p:spPr/>
+        <p:txBody>
+          <a:bodyPr/>
+          <a:lstStyle/>
+          <a:p>
+            <a:r>
+              <a:rPr lang="he-IL" dirty="0"/>
+              <a:t>מבנה כללי של המערכת</a:t>
+            </a:r>
+          </a:p>
+        </p:txBody>
+      </p:sp>
+      <p:sp>
+        <p:nvSpPr>
+          <p:cNvPr id="3" name="מציין מיקום תוכן 2">
+            <a:extLst>
+              <a:ext uri="{FF2B5EF4-FFF2-40B4-BE49-F238E27FC236}">
+                <a16:creationId xmlns:a16="http://schemas.microsoft.com/office/drawing/2014/main" id="{49649860-CFCA-527F-0800-9F7095A6AE35}"/>
+              </a:ext>
+            </a:extLst>
+          </p:cNvPr>
+          <p:cNvSpPr>
+            <a:spLocks noGrp="1"/>
+          </p:cNvSpPr>
+          <p:nvPr>
+            <p:ph idx="1"/>
+          </p:nvPr>
+        </p:nvSpPr>
+        <p:spPr/>
+        <p:txBody>
+          <a:bodyPr/>
+          <a:lstStyle/>
+          <a:p>
+            <a:r>
+              <a:rPr lang="he-IL" dirty="0"/>
+              <a:t>התחברות</a:t>
+            </a:r>
+          </a:p>
+          <a:p>
+            <a:r>
+              <a:rPr lang="he-IL" dirty="0"/>
+              <a:t>ניתוב לפי תפקיד</a:t>
+            </a:r>
+          </a:p>
+          <a:p>
+            <a:r>
+              <a:rPr lang="he-IL" dirty="0"/>
+              <a:t>אזורי מערכת: מורות / תלמידות / צוות ניהולי + טיפולי / ניהול</a:t>
+            </a:r>
+          </a:p>
+        </p:txBody>
+      </p:sp>
+    </p:spTree>
+    <p:extLst>
+      <p:ext uri="{BB962C8B-B14F-4D97-AF65-F5344CB8AC3E}">
+        <p14:creationId xmlns:p14="http://schemas.microsoft.com/office/powerpoint/2010/main" val="3023551992"/>
+      </p:ext>
+    </p:extLst>
+  </p:cSld>
+  <p:clrMapOvr>
+    <a:masterClrMapping/>
+  </p:clrMapOvr>
+</p:sld>
+</file>
+
+<file path=ppt/slides/slide7.xml><?xml version="1.0" encoding="utf-8"?>
+<p:sld xmlns:a="http://schemas.openxmlformats.org/drawingml/2006/main" xmlns:r="http://schemas.openxmlformats.org/officeDocument/2006/relationships" xmlns:p="http://schemas.openxmlformats.org/presentationml/2006/main">
+  <p:cSld>
+    <p:spTree>
+      <p:nvGrpSpPr>
+        <p:cNvPr id="1" name=""/>
+        <p:cNvGrpSpPr/>
+        <p:nvPr/>
+      </p:nvGrpSpPr>
+      <p:grpSpPr>
+        <a:xfrm>
+          <a:off x="0" y="0"/>
+          <a:ext cx="0" cy="0"/>
+          <a:chOff x="0" y="0"/>
+          <a:chExt cx="0" cy="0"/>
+        </a:xfrm>
+      </p:grpSpPr>
+      <p:sp>
+        <p:nvSpPr>
+          <p:cNvPr id="2" name="כותרת 1">
+            <a:extLst>
+              <a:ext uri="{FF2B5EF4-FFF2-40B4-BE49-F238E27FC236}">
+                <a16:creationId xmlns:a16="http://schemas.microsoft.com/office/drawing/2014/main" id="{E2F8CC42-868E-897E-6BC8-4D210ADAC4D5}"/>
+              </a:ext>
+            </a:extLst>
+          </p:cNvPr>
+          <p:cNvSpPr>
+            <a:spLocks noGrp="1"/>
+          </p:cNvSpPr>
+          <p:nvPr>
+            <p:ph type="title"/>
+          </p:nvPr>
+        </p:nvSpPr>
+        <p:spPr/>
+        <p:txBody>
+          <a:bodyPr/>
+          <a:lstStyle/>
+          <a:p>
+            <a:r>
+              <a:rPr lang="he-IL" dirty="0"/>
+              <a:t>מסכי מערכת </a:t>
+            </a:r>
+          </a:p>
+        </p:txBody>
+      </p:sp>
+      <p:sp>
+        <p:nvSpPr>
+          <p:cNvPr id="3" name="מציין מיקום תוכן 2">
+            <a:extLst>
+              <a:ext uri="{FF2B5EF4-FFF2-40B4-BE49-F238E27FC236}">
+                <a16:creationId xmlns:a16="http://schemas.microsoft.com/office/drawing/2014/main" id="{DBF4F25E-546D-919F-EBE1-EC275F57C1FF}"/>
+              </a:ext>
+            </a:extLst>
+          </p:cNvPr>
+          <p:cNvSpPr>
+            <a:spLocks noGrp="1"/>
+          </p:cNvSpPr>
+          <p:nvPr>
+            <p:ph idx="1"/>
+          </p:nvPr>
+        </p:nvSpPr>
+        <p:spPr/>
+        <p:txBody>
+          <a:bodyPr/>
+          <a:lstStyle/>
+          <a:p>
+            <a:r>
+              <a:rPr lang="he-IL" dirty="0"/>
+              <a:t>צד מורות </a:t>
+            </a:r>
+          </a:p>
+          <a:p>
+            <a:pPr lvl="1"/>
+            <a:r>
+              <a:rPr lang="he-IL" dirty="0"/>
+              <a:t>הזנת נקודות + צפיה בנתונים קודמים (ניהול יומן מפורט)</a:t>
+            </a:r>
+          </a:p>
+          <a:p>
+            <a:pPr lvl="1"/>
+            <a:r>
+              <a:rPr lang="he-IL" dirty="0"/>
+              <a:t>גרפים</a:t>
+            </a:r>
+          </a:p>
+          <a:p>
+            <a:pPr lvl="1"/>
+            <a:r>
+              <a:rPr lang="he-IL" dirty="0"/>
+              <a:t>הודעות לתמידות</a:t>
+            </a:r>
+          </a:p>
+        </p:txBody>
+      </p:sp>
+    </p:spTree>
+    <p:extLst>
+      <p:ext uri="{BB962C8B-B14F-4D97-AF65-F5344CB8AC3E}">
+        <p14:creationId xmlns:p14="http://schemas.microsoft.com/office/powerpoint/2010/main" val="3246983325"/>
+      </p:ext>
+    </p:extLst>
+  </p:cSld>
+  <p:clrMapOvr>
+    <a:masterClrMapping/>
+  </p:clrMapOvr>
+</p:sld>
+</file>
+
+<file path=ppt/slides/slide8.xml><?xml version="1.0" encoding="utf-8"?>
+<p:sld xmlns:a="http://schemas.openxmlformats.org/drawingml/2006/main" xmlns:r="http://schemas.openxmlformats.org/officeDocument/2006/relationships" xmlns:p="http://schemas.openxmlformats.org/presentationml/2006/main">
+  <p:cSld>
+    <p:spTree>
+      <p:nvGrpSpPr>
+        <p:cNvPr id="1" name=""/>
+        <p:cNvGrpSpPr/>
+        <p:nvPr/>
+      </p:nvGrpSpPr>
+      <p:grpSpPr>
+        <a:xfrm>
+          <a:off x="0" y="0"/>
+          <a:ext cx="0" cy="0"/>
+          <a:chOff x="0" y="0"/>
+          <a:chExt cx="0" cy="0"/>
+        </a:xfrm>
+      </p:grpSpPr>
+      <p:sp>
+        <p:nvSpPr>
+          <p:cNvPr id="2" name="כותרת 1">
+            <a:extLst>
+              <a:ext uri="{FF2B5EF4-FFF2-40B4-BE49-F238E27FC236}">
+                <a16:creationId xmlns:a16="http://schemas.microsoft.com/office/drawing/2014/main" id="{D1F43BDC-28F0-4D90-2A69-899EA20E1F2A}"/>
+              </a:ext>
+            </a:extLst>
+          </p:cNvPr>
+          <p:cNvSpPr>
+            <a:spLocks noGrp="1"/>
+          </p:cNvSpPr>
+          <p:nvPr>
+            <p:ph type="title"/>
+          </p:nvPr>
+        </p:nvSpPr>
+        <p:spPr/>
+        <p:txBody>
+          <a:bodyPr/>
+          <a:lstStyle/>
+          <a:p>
+            <a:r>
+              <a:rPr lang="he-IL" dirty="0"/>
+              <a:t>מסכי מערכת </a:t>
+            </a:r>
+          </a:p>
+        </p:txBody>
+      </p:sp>
+      <p:sp>
+        <p:nvSpPr>
+          <p:cNvPr id="3" name="מציין מיקום תוכן 2">
+            <a:extLst>
+              <a:ext uri="{FF2B5EF4-FFF2-40B4-BE49-F238E27FC236}">
+                <a16:creationId xmlns:a16="http://schemas.microsoft.com/office/drawing/2014/main" id="{30F475EA-41AB-2432-5F3F-5F56C8CF2C95}"/>
+              </a:ext>
+            </a:extLst>
+          </p:cNvPr>
+          <p:cNvSpPr>
+            <a:spLocks noGrp="1"/>
+          </p:cNvSpPr>
+          <p:nvPr>
+            <p:ph idx="1"/>
+          </p:nvPr>
+        </p:nvSpPr>
+        <p:spPr/>
+        <p:txBody>
+          <a:bodyPr/>
+          <a:lstStyle/>
+          <a:p>
+            <a:r>
+              <a:rPr lang="he-IL" dirty="0"/>
+              <a:t>צד תלמידות</a:t>
+            </a:r>
+          </a:p>
+          <a:p>
+            <a:pPr lvl="1"/>
+            <a:r>
+              <a:rPr lang="he-IL" dirty="0"/>
+              <a:t>פרופיל אישי – סיכום שבועי של נקודות, שוברים, תעודות הצטיינות, הודעות מצוות, מפת הדרך להצטיינות חודשית</a:t>
+            </a:r>
+          </a:p>
+          <a:p>
+            <a:pPr lvl="1"/>
+            <a:r>
+              <a:rPr lang="he-IL" dirty="0"/>
+              <a:t>גרפים</a:t>
+            </a:r>
+          </a:p>
+          <a:p>
+            <a:pPr lvl="1"/>
+            <a:r>
+              <a:rPr lang="he-IL" dirty="0"/>
+              <a:t>הודעות לצוות ניהול האתר</a:t>
+            </a:r>
+          </a:p>
+        </p:txBody>
+      </p:sp>
+    </p:spTree>
+    <p:extLst>
+      <p:ext uri="{BB962C8B-B14F-4D97-AF65-F5344CB8AC3E}">
+        <p14:creationId xmlns:p14="http://schemas.microsoft.com/office/powerpoint/2010/main" val="2844655302"/>
+      </p:ext>
+    </p:extLst>
+  </p:cSld>
+  <p:clrMapOvr>
+    <a:masterClrMapping/>
+  </p:clrMapOvr>
+</p:sld>
+</file>
+
+<file path=ppt/slides/slide9.xml><?xml version="1.0" encoding="utf-8"?>
+<p:sld xmlns:a="http://schemas.openxmlformats.org/drawingml/2006/main" xmlns:r="http://schemas.openxmlformats.org/officeDocument/2006/relationships" xmlns:p="http://schemas.openxmlformats.org/presentationml/2006/main">
+  <p:cSld>
+    <p:spTree>
+      <p:nvGrpSpPr>
+        <p:cNvPr id="1" name=""/>
+        <p:cNvGrpSpPr/>
+        <p:nvPr/>
+      </p:nvGrpSpPr>
+      <p:grpSpPr>
+        <a:xfrm>
+          <a:off x="0" y="0"/>
+          <a:ext cx="0" cy="0"/>
+          <a:chOff x="0" y="0"/>
+          <a:chExt cx="0" cy="0"/>
+        </a:xfrm>
+      </p:grpSpPr>
+      <p:sp>
+        <p:nvSpPr>
+          <p:cNvPr id="2" name="כותרת 1">
+            <a:extLst>
+              <a:ext uri="{FF2B5EF4-FFF2-40B4-BE49-F238E27FC236}">
+                <a16:creationId xmlns:a16="http://schemas.microsoft.com/office/drawing/2014/main" id="{099173E5-D2C3-3309-91E8-C1E460665084}"/>
+              </a:ext>
+            </a:extLst>
+          </p:cNvPr>
+          <p:cNvSpPr>
+            <a:spLocks noGrp="1"/>
+          </p:cNvSpPr>
+          <p:nvPr>
+            <p:ph type="title"/>
+          </p:nvPr>
+        </p:nvSpPr>
+        <p:spPr/>
+        <p:txBody>
+          <a:bodyPr/>
+          <a:lstStyle/>
+          <a:p>
+            <a:r>
+              <a:rPr lang="he-IL" dirty="0"/>
+              <a:t>הקיוסק הדיגיטלי ומימוש שוברים</a:t>
+            </a:r>
+          </a:p>
+        </p:txBody>
+      </p:sp>
+      <p:sp>
+        <p:nvSpPr>
+          <p:cNvPr id="3" name="מציין מיקום תוכן 2">
+            <a:extLst>
+              <a:ext uri="{FF2B5EF4-FFF2-40B4-BE49-F238E27FC236}">
+                <a16:creationId xmlns:a16="http://schemas.microsoft.com/office/drawing/2014/main" id="{3530E923-7361-0489-6248-E2A40B841B3C}"/>
+              </a:ext>
+            </a:extLst>
+          </p:cNvPr>
+          <p:cNvSpPr>
+            <a:spLocks noGrp="1"/>
+          </p:cNvSpPr>
+          <p:nvPr>
+            <p:ph idx="1"/>
+          </p:nvPr>
+        </p:nvSpPr>
+        <p:spPr/>
+        <p:txBody>
+          <a:bodyPr/>
+          <a:lstStyle/>
+          <a:p>
+            <a:r>
+              <a:rPr lang="he-IL" dirty="0"/>
+              <a:t>צפייה במוצרים </a:t>
+            </a:r>
+          </a:p>
+          <a:p>
+            <a:r>
+              <a:rPr lang="he-IL" dirty="0"/>
+              <a:t>סינון לפי קטגוריות או חיפוש</a:t>
+            </a:r>
+          </a:p>
+          <a:p>
+            <a:r>
+              <a:rPr lang="he-IL" dirty="0"/>
+              <a:t>סל קניות</a:t>
+            </a:r>
+          </a:p>
+          <a:p>
+            <a:r>
+              <a:rPr lang="he-IL" dirty="0"/>
+              <a:t>תהליך רכישה</a:t>
+            </a:r>
+          </a:p>
+          <a:p>
+            <a:r>
+              <a:rPr lang="he-IL" dirty="0"/>
+              <a:t>אישור והתראות </a:t>
+            </a:r>
+          </a:p>
+          <a:p>
+            <a:r>
+              <a:rPr lang="he-IL" dirty="0"/>
+              <a:t>הזמנות ומיילים - למנהלת האתר על ביצוע ההזמנה </a:t>
+            </a:r>
+          </a:p>
+        </p:txBody>
+      </p:sp>
+    </p:spTree>
+    <p:extLst>
+      <p:ext uri="{BB962C8B-B14F-4D97-AF65-F5344CB8AC3E}">
+        <p14:creationId xmlns:p14="http://schemas.microsoft.com/office/powerpoint/2010/main" val="1213945203"/>
       </p:ext>
     </p:extLst>
   </p:cSld>
@@ -4056,4 +7126,299 @@
     </a:ext>
   </a:extLst>
 </a:theme>
+</file>
+
+<file path=ppt/theme/theme2.xml><?xml version="1.0" encoding="utf-8"?>
+<a:theme xmlns:a="http://schemas.openxmlformats.org/drawingml/2006/main" name="ערכת נושא Office">
+  <a:themeElements>
+    <a:clrScheme name="Office">
+      <a:dk1>
+        <a:sysClr val="windowText" lastClr="000000"/>
+      </a:dk1>
+      <a:lt1>
+        <a:sysClr val="window" lastClr="FFFFFF"/>
+      </a:lt1>
+      <a:dk2>
+        <a:srgbClr val="44546A"/>
+      </a:dk2>
+      <a:lt2>
+        <a:srgbClr val="E7E6E6"/>
+      </a:lt2>
+      <a:accent1>
+        <a:srgbClr val="4472C4"/>
+      </a:accent1>
+      <a:accent2>
+        <a:srgbClr val="ED7D31"/>
+      </a:accent2>
+      <a:accent3>
+        <a:srgbClr val="A5A5A5"/>
+      </a:accent3>
+      <a:accent4>
+        <a:srgbClr val="FFC000"/>
+      </a:accent4>
+      <a:accent5>
+        <a:srgbClr val="5B9BD5"/>
+      </a:accent5>
+      <a:accent6>
+        <a:srgbClr val="70AD47"/>
+      </a:accent6>
+      <a:hlink>
+        <a:srgbClr val="0563C1"/>
+      </a:hlink>
+      <a:folHlink>
+        <a:srgbClr val="954F72"/>
+      </a:folHlink>
+    </a:clrScheme>
+    <a:fontScheme name="Office">
+      <a:majorFont>
+        <a:latin typeface="Calibri Light" panose="020F0302020204030204"/>
+        <a:ea typeface=""/>
+        <a:cs typeface=""/>
+        <a:font script="Jpan" typeface="游ゴシック Light"/>
+        <a:font script="Hang" typeface="맑은 고딕"/>
+        <a:font script="Hans" typeface="等线 Light"/>
+        <a:font script="Hant" typeface="新細明體"/>
+        <a:font script="Arab" typeface="Times New Roman"/>
+        <a:font script="Hebr" typeface="Times New Roman"/>
+        <a:font script="Thai" typeface="Angsana New"/>
+        <a:font script="Ethi" typeface="Nyala"/>
+        <a:font script="Beng" typeface="Vrinda"/>
+        <a:font script="Gujr" typeface="Shruti"/>
+        <a:font script="Khmr" typeface="MoolBoran"/>
+        <a:font script="Knda" typeface="Tunga"/>
+        <a:font script="Guru" typeface="Raavi"/>
+        <a:font script="Cans" typeface="Euphemia"/>
+        <a:font script="Cher" typeface="Plantagenet Cherokee"/>
+        <a:font script="Yiii" typeface="Microsoft Yi Baiti"/>
+        <a:font script="Tibt" typeface="Microsoft Himalaya"/>
+        <a:font script="Thaa" typeface="MV Boli"/>
+        <a:font script="Deva" typeface="Mangal"/>
+        <a:font script="Telu" typeface="Gautami"/>
+        <a:font script="Taml" typeface="Latha"/>
+        <a:font script="Syrc" typeface="Estrangelo Edessa"/>
+        <a:font script="Orya" typeface="Kalinga"/>
+        <a:font script="Mlym" typeface="Kartika"/>
+        <a:font script="Laoo" typeface="DokChampa"/>
+        <a:font script="Sinh" typeface="Iskoola Pota"/>
+        <a:font script="Mong" typeface="Mongolian Baiti"/>
+        <a:font script="Viet" typeface="Times New Roman"/>
+        <a:font script="Uigh" typeface="Microsoft Uighur"/>
+        <a:font script="Geor" typeface="Sylfaen"/>
+        <a:font script="Armn" typeface="Arial"/>
+        <a:font script="Bugi" typeface="Leelawadee UI"/>
+        <a:font script="Bopo" typeface="Microsoft JhengHei"/>
+        <a:font script="Java" typeface="Javanese Text"/>
+        <a:font script="Lisu" typeface="Segoe UI"/>
+        <a:font script="Mymr" typeface="Myanmar Text"/>
+        <a:font script="Nkoo" typeface="Ebrima"/>
+        <a:font script="Olck" typeface="Nirmala UI"/>
+        <a:font script="Osma" typeface="Ebrima"/>
+        <a:font script="Phag" typeface="Phagspa"/>
+        <a:font script="Syrn" typeface="Estrangelo Edessa"/>
+        <a:font script="Syrj" typeface="Estrangelo Edessa"/>
+        <a:font script="Syre" typeface="Estrangelo Edessa"/>
+        <a:font script="Sora" typeface="Nirmala UI"/>
+        <a:font script="Tale" typeface="Microsoft Tai Le"/>
+        <a:font script="Talu" typeface="Microsoft New Tai Lue"/>
+        <a:font script="Tfng" typeface="Ebrima"/>
+      </a:majorFont>
+      <a:minorFont>
+        <a:latin typeface="Calibri" panose="020F0502020204030204"/>
+        <a:ea typeface=""/>
+        <a:cs typeface=""/>
+        <a:font script="Jpan" typeface="游ゴシック"/>
+        <a:font script="Hang" typeface="맑은 고딕"/>
+        <a:font script="Hans" typeface="等线"/>
+        <a:font script="Hant" typeface="新細明體"/>
+        <a:font script="Arab" typeface="Arial"/>
+        <a:font script="Hebr" typeface="Arial"/>
+        <a:font script="Thai" typeface="Cordia New"/>
+        <a:font script="Ethi" typeface="Nyala"/>
+        <a:font script="Beng" typeface="Vrinda"/>
+        <a:font script="Gujr" typeface="Shruti"/>
+        <a:font script="Khmr" typeface="DaunPenh"/>
+        <a:font script="Knda" typeface="Tunga"/>
+        <a:font script="Guru" typeface="Raavi"/>
+        <a:font script="Cans" typeface="Euphemia"/>
+        <a:font script="Cher" typeface="Plantagenet Cherokee"/>
+        <a:font script="Yiii" typeface="Microsoft Yi Baiti"/>
+        <a:font script="Tibt" typeface="Microsoft Himalaya"/>
+        <a:font script="Thaa" typeface="MV Boli"/>
+        <a:font script="Deva" typeface="Mangal"/>
+        <a:font script="Telu" typeface="Gautami"/>
+        <a:font script="Taml" typeface="Latha"/>
+        <a:font script="Syrc" typeface="Estrangelo Edessa"/>
+        <a:font script="Orya" typeface="Kalinga"/>
+        <a:font script="Mlym" typeface="Kartika"/>
+        <a:font script="Laoo" typeface="DokChampa"/>
+        <a:font script="Sinh" typeface="Iskoola Pota"/>
+        <a:font script="Mong" typeface="Mongolian Baiti"/>
+        <a:font script="Viet" typeface="Arial"/>
+        <a:font script="Uigh" typeface="Microsoft Uighur"/>
+        <a:font script="Geor" typeface="Sylfaen"/>
+        <a:font script="Armn" typeface="Arial"/>
+        <a:font script="Bugi" typeface="Leelawadee UI"/>
+        <a:font script="Bopo" typeface="Microsoft JhengHei"/>
+        <a:font script="Java" typeface="Javanese Text"/>
+        <a:font script="Lisu" typeface="Segoe UI"/>
+        <a:font script="Mymr" typeface="Myanmar Text"/>
+        <a:font script="Nkoo" typeface="Ebrima"/>
+        <a:font script="Olck" typeface="Nirmala UI"/>
+        <a:font script="Osma" typeface="Ebrima"/>
+        <a:font script="Phag" typeface="Phagspa"/>
+        <a:font script="Syrn" typeface="Estrangelo Edessa"/>
+        <a:font script="Syrj" typeface="Estrangelo Edessa"/>
+        <a:font script="Syre" typeface="Estrangelo Edessa"/>
+        <a:font script="Sora" typeface="Nirmala UI"/>
+        <a:font script="Tale" typeface="Microsoft Tai Le"/>
+        <a:font script="Talu" typeface="Microsoft New Tai Lue"/>
+        <a:font script="Tfng" typeface="Ebrima"/>
+      </a:minorFont>
+    </a:fontScheme>
+    <a:fmtScheme name="Office">
+      <a:fillStyleLst>
+        <a:solidFill>
+          <a:schemeClr val="phClr"/>
+        </a:solidFill>
+        <a:gradFill rotWithShape="1">
+          <a:gsLst>
+            <a:gs pos="0">
+              <a:schemeClr val="phClr">
+                <a:lumMod val="110000"/>
+                <a:satMod val="105000"/>
+                <a:tint val="67000"/>
+              </a:schemeClr>
+            </a:gs>
+            <a:gs pos="50000">
+              <a:schemeClr val="phClr">
+                <a:lumMod val="105000"/>
+                <a:satMod val="103000"/>
+                <a:tint val="73000"/>
+              </a:schemeClr>
+            </a:gs>
+            <a:gs pos="100000">
+              <a:schemeClr val="phClr">
+                <a:lumMod val="105000"/>
+                <a:satMod val="109000"/>
+                <a:tint val="81000"/>
+              </a:schemeClr>
+            </a:gs>
+          </a:gsLst>
+          <a:lin ang="5400000" scaled="0"/>
+        </a:gradFill>
+        <a:gradFill rotWithShape="1">
+          <a:gsLst>
+            <a:gs pos="0">
+              <a:schemeClr val="phClr">
+                <a:satMod val="103000"/>
+                <a:lumMod val="102000"/>
+                <a:tint val="94000"/>
+              </a:schemeClr>
+            </a:gs>
+            <a:gs pos="50000">
+              <a:schemeClr val="phClr">
+                <a:satMod val="110000"/>
+                <a:lumMod val="100000"/>
+                <a:shade val="100000"/>
+              </a:schemeClr>
+            </a:gs>
+            <a:gs pos="100000">
+              <a:schemeClr val="phClr">
+                <a:lumMod val="99000"/>
+                <a:satMod val="120000"/>
+                <a:shade val="78000"/>
+              </a:schemeClr>
+            </a:gs>
+          </a:gsLst>
+          <a:lin ang="5400000" scaled="0"/>
+        </a:gradFill>
+      </a:fillStyleLst>
+      <a:lnStyleLst>
+        <a:ln w="6350" cap="flat" cmpd="sng" algn="ctr">
+          <a:solidFill>
+            <a:schemeClr val="phClr"/>
+          </a:solidFill>
+          <a:prstDash val="solid"/>
+          <a:miter lim="800000"/>
+        </a:ln>
+        <a:ln w="12700" cap="flat" cmpd="sng" algn="ctr">
+          <a:solidFill>
+            <a:schemeClr val="phClr"/>
+          </a:solidFill>
+          <a:prstDash val="solid"/>
+          <a:miter lim="800000"/>
+        </a:ln>
+        <a:ln w="19050" cap="flat" cmpd="sng" algn="ctr">
+          <a:solidFill>
+            <a:schemeClr val="phClr"/>
+          </a:solidFill>
+          <a:prstDash val="solid"/>
+          <a:miter lim="800000"/>
+        </a:ln>
+      </a:lnStyleLst>
+      <a:effectStyleLst>
+        <a:effectStyle>
+          <a:effectLst/>
+        </a:effectStyle>
+        <a:effectStyle>
+          <a:effectLst/>
+        </a:effectStyle>
+        <a:effectStyle>
+          <a:effectLst>
+            <a:outerShdw blurRad="57150" dist="19050" dir="5400000" algn="ctr" rotWithShape="0">
+              <a:srgbClr val="000000">
+                <a:alpha val="63000"/>
+              </a:srgbClr>
+            </a:outerShdw>
+          </a:effectLst>
+        </a:effectStyle>
+      </a:effectStyleLst>
+      <a:bgFillStyleLst>
+        <a:solidFill>
+          <a:schemeClr val="phClr"/>
+        </a:solidFill>
+        <a:solidFill>
+          <a:schemeClr val="phClr">
+            <a:tint val="95000"/>
+            <a:satMod val="170000"/>
+          </a:schemeClr>
+        </a:solidFill>
+        <a:gradFill rotWithShape="1">
+          <a:gsLst>
+            <a:gs pos="0">
+              <a:schemeClr val="phClr">
+                <a:tint val="93000"/>
+                <a:satMod val="150000"/>
+                <a:shade val="98000"/>
+                <a:lumMod val="102000"/>
+              </a:schemeClr>
+            </a:gs>
+            <a:gs pos="50000">
+              <a:schemeClr val="phClr">
+                <a:tint val="98000"/>
+                <a:satMod val="130000"/>
+                <a:shade val="90000"/>
+                <a:lumMod val="103000"/>
+              </a:schemeClr>
+            </a:gs>
+            <a:gs pos="100000">
+              <a:schemeClr val="phClr">
+                <a:shade val="63000"/>
+                <a:satMod val="120000"/>
+              </a:schemeClr>
+            </a:gs>
+          </a:gsLst>
+          <a:lin ang="5400000" scaled="0"/>
+        </a:gradFill>
+      </a:bgFillStyleLst>
+    </a:fmtScheme>
+  </a:themeElements>
+  <a:objectDefaults/>
+  <a:extraClrSchemeLst/>
+  <a:extLst>
+    <a:ext uri="{05A4C25C-085E-4340-85A3-A5531E510DB2}">
+      <thm15:themeFamily xmlns:thm15="http://schemas.microsoft.com/office/thememl/2012/main" name="Office Theme" id="{62F939B6-93AF-4DB8-9C6B-D6C7DFDC589F}" vid="{4A3C46E8-61CC-4603-A589-7422A47A8E4A}"/>
+    </a:ext>
+  </a:extLst>
+</a:theme>
 </file>
</xml_diff>